<commit_message>
Cambio de 2 hojas en ppt
</commit_message>
<xml_diff>
--- a/presentacion/GraphQL-vs-REST.pptx
+++ b/presentacion/GraphQL-vs-REST.pptx
@@ -9,6 +9,7 @@
   </p:notesMasterIdLst>
   <p:sldIdLst>
     <p:sldId id="256" r:id="rId2"/>
+    <p:sldId id="264" r:id="rId15"/>
     <p:sldId id="257" r:id="rId3"/>
     <p:sldId id="258" r:id="rId4"/>
     <p:sldId id="259" r:id="rId5"/>
@@ -16,6 +17,7 @@
     <p:sldId id="261" r:id="rId7"/>
     <p:sldId id="262" r:id="rId8"/>
     <p:sldId id="263" r:id="rId9"/>
+    <p:sldId id="265" r:id="rId16"/>
   </p:sldIdLst>
   <p:sldSz cx="9144000" cy="5143500" type="screen16x9"/>
   <p:notesSz cx="5143500" cy="9144000"/>
@@ -2134,6 +2136,572 @@
 </p:sld>
 </file>
 
+<file path=ppt/slides/slide10.xml><?xml version="1.0" encoding="utf-8"?>
+<p:sld xmlns:a="http://schemas.openxmlformats.org/drawingml/2006/main" xmlns:r="http://schemas.openxmlformats.org/officeDocument/2006/relationships" xmlns:p="http://schemas.openxmlformats.org/presentationml/2006/main">
+  <p:cSld name="Cierre">
+    <p:bg>
+      <p:bgPr>
+        <a:solidFill>
+          <a:srgbClr val="F6EEF6"/>
+        </a:solidFill>
+        <a:effectLst/>
+      </p:bgPr>
+    </p:bg>
+    <p:spTree>
+      <p:nvGrpSpPr>
+        <p:cNvPr id="1" name=""/>
+        <p:cNvGrpSpPr/>
+        <p:nvPr/>
+      </p:nvGrpSpPr>
+      <p:grpSpPr>
+        <a:xfrm>
+          <a:off x="0" y="0"/>
+          <a:ext cx="0" cy="0"/>
+          <a:chOff x="0" y="0"/>
+          <a:chExt cx="0" cy="0"/>
+        </a:xfrm>
+      </p:grpSpPr>
+      <p:sp>
+        <p:nvSpPr>
+          <p:cNvPr id="123" name="Titulo 123"/>
+          <p:cNvSpPr txBox="1"/>
+          <p:nvPr/>
+        </p:nvSpPr>
+        <p:spPr>
+          <a:xfrm>
+            <a:off x="548640" y="1325880"/>
+            <a:ext cx="4937760" cy="1371600"/>
+          </a:xfrm>
+          <a:prstGeom prst="rect">
+            <a:avLst/>
+          </a:prstGeom>
+          <a:noFill/>
+          <a:ln/>
+        </p:spPr>
+        <p:txBody>
+          <a:bodyPr wrap="square" lIns="0" tIns="0" rIns="0" bIns="0" rtlCol="0" anchor="b"/>
+          <a:lstStyle/>
+          <a:p>
+            <a:pPr marL="0" indent="0">
+              <a:buNone/>
+            </a:pPr>
+            <a:r>
+              <a:rPr lang="es-AR" sz="2800" dirty="0">
+                <a:solidFill>
+                  <a:srgbClr val="1B1F3B"/>
+                </a:solidFill>
+                <a:latin typeface="Cambria" pitchFamily="34" charset="0"/>
+                <a:ea typeface="Cambria" pitchFamily="34" charset="-122"/>
+                <a:cs typeface="Cambria" pitchFamily="34" charset="-120"/>
+              </a:rPr>
+              <a:t>Esto es</a:t>
+            </a:r>
+          </a:p>
+          <a:p>
+            <a:pPr marL="0" indent="0">
+              <a:buNone/>
+            </a:pPr>
+            <a:r>
+              <a:rPr lang="es-AR" sz="5400" b="1" dirty="0">
+                <a:solidFill>
+                  <a:srgbClr val="E10098"/>
+                </a:solidFill>
+                <a:latin typeface="Cambria" pitchFamily="34" charset="0"/>
+                <a:ea typeface="Cambria" pitchFamily="34" charset="-122"/>
+                <a:cs typeface="Cambria" pitchFamily="34" charset="-120"/>
+              </a:rPr>
+              <a:t>GraphQL</a:t>
+            </a:r>
+          </a:p>
+        </p:txBody>
+      </p:sp>
+      <p:sp>
+        <p:nvSpPr>
+          <p:cNvPr id="124" name="Preguntas 124"/>
+          <p:cNvSpPr txBox="1"/>
+          <p:nvPr/>
+        </p:nvSpPr>
+        <p:spPr>
+          <a:xfrm>
+            <a:off x="548640" y="2926080"/>
+            <a:ext cx="4937760" cy="731520"/>
+          </a:xfrm>
+          <a:prstGeom prst="rect">
+            <a:avLst/>
+          </a:prstGeom>
+          <a:noFill/>
+          <a:ln/>
+        </p:spPr>
+        <p:txBody>
+          <a:bodyPr wrap="square" lIns="0" tIns="0" rIns="0" bIns="0" rtlCol="0" anchor="ctr"/>
+          <a:lstStyle/>
+          <a:p>
+            <a:pPr marL="0" indent="0">
+              <a:buNone/>
+            </a:pPr>
+            <a:r>
+              <a:rPr lang="es-AR" sz="4000" b="1" dirty="0">
+                <a:solidFill>
+                  <a:srgbClr val="1B1F3B"/>
+                </a:solidFill>
+                <a:latin typeface="Cambria" pitchFamily="34" charset="0"/>
+                <a:ea typeface="Cambria" pitchFamily="34" charset="-122"/>
+                <a:cs typeface="Cambria" pitchFamily="34" charset="-120"/>
+              </a:rPr>
+              <a:t>¿Preguntas?</a:t>
+            </a:r>
+          </a:p>
+        </p:txBody>
+      </p:sp>
+      <p:sp>
+        <p:nvSpPr>
+          <p:cNvPr id="13" name="Text 10"/>
+          <p:cNvSpPr txBox="1"/>
+          <p:nvPr/>
+        </p:nvSpPr>
+        <p:spPr>
+          <a:xfrm>
+            <a:off x="548640" y="4663440"/>
+            <a:ext cx="4937760" cy="274320"/>
+          </a:xfrm>
+          <a:prstGeom prst="rect">
+            <a:avLst/>
+          </a:prstGeom>
+          <a:noFill/>
+          <a:ln/>
+        </p:spPr>
+        <p:txBody>
+          <a:bodyPr wrap="square" lIns="0" tIns="0" rIns="0" bIns="0" rtlCol="0" anchor="ctr"/>
+          <a:lstStyle/>
+          <a:p>
+            <a:pPr marL="0" indent="0">
+              <a:buNone/>
+            </a:pPr>
+            <a:r>
+              <a:rPr lang="en-US" sz="1200" dirty="0">
+                <a:solidFill>
+                  <a:srgbClr val="5B6178"/>
+                </a:solidFill>
+                <a:latin typeface="Calibri" pitchFamily="34" charset="0"/>
+                <a:ea typeface="Calibri" pitchFamily="34" charset="-122"/>
+                <a:cs typeface="Calibri" pitchFamily="34" charset="-120"/>
+              </a:rPr>
+              <a:t>Gamba y Milanesi · 2026</a:t>
+            </a:r>
+            <a:endParaRPr lang="en-US" sz="1200" dirty="0"/>
+          </a:p>
+        </p:txBody>
+      </p:sp>
+      <p:sp>
+        <p:nvSpPr>
+          <p:cNvPr id="14" name="Shape 11"/>
+          <p:cNvSpPr/>
+          <p:nvPr/>
+        </p:nvSpPr>
+        <p:spPr>
+          <a:xfrm>
+            <a:off x="6583680" y="1188720"/>
+            <a:ext cx="1463040" cy="548640"/>
+          </a:xfrm>
+          <a:prstGeom prst="line">
+            <a:avLst/>
+          </a:prstGeom>
+          <a:noFill/>
+          <a:ln w="19050">
+            <a:solidFill>
+              <a:srgbClr val="E10098"/>
+            </a:solidFill>
+            <a:prstDash val="solid"/>
+          </a:ln>
+        </p:spPr>
+        <p:txBody>
+          <a:bodyPr/>
+          <a:lstStyle/>
+          <a:p>
+            <a:endParaRPr lang="es-AR"/>
+          </a:p>
+        </p:txBody>
+      </p:sp>
+      <p:sp>
+        <p:nvSpPr>
+          <p:cNvPr id="15" name="Shape 12"/>
+          <p:cNvSpPr/>
+          <p:nvPr/>
+        </p:nvSpPr>
+        <p:spPr>
+          <a:xfrm>
+            <a:off x="6583680" y="1188720"/>
+            <a:ext cx="365760" cy="1463040"/>
+          </a:xfrm>
+          <a:prstGeom prst="line">
+            <a:avLst/>
+          </a:prstGeom>
+          <a:noFill/>
+          <a:ln w="19050">
+            <a:solidFill>
+              <a:srgbClr val="E10098"/>
+            </a:solidFill>
+            <a:prstDash val="solid"/>
+          </a:ln>
+        </p:spPr>
+        <p:txBody>
+          <a:bodyPr/>
+          <a:lstStyle/>
+          <a:p>
+            <a:endParaRPr lang="es-AR"/>
+          </a:p>
+        </p:txBody>
+      </p:sp>
+      <p:sp>
+        <p:nvSpPr>
+          <p:cNvPr id="16" name="Shape 13"/>
+          <p:cNvSpPr/>
+          <p:nvPr/>
+        </p:nvSpPr>
+        <p:spPr>
+          <a:xfrm flipV="1">
+            <a:off x="6949440" y="1737360"/>
+            <a:ext cx="1097280" cy="914400"/>
+          </a:xfrm>
+          <a:prstGeom prst="line">
+            <a:avLst/>
+          </a:prstGeom>
+          <a:noFill/>
+          <a:ln w="19050">
+            <a:solidFill>
+              <a:srgbClr val="E10098"/>
+            </a:solidFill>
+            <a:prstDash val="solid"/>
+          </a:ln>
+        </p:spPr>
+        <p:txBody>
+          <a:bodyPr/>
+          <a:lstStyle/>
+          <a:p>
+            <a:endParaRPr lang="es-AR"/>
+          </a:p>
+        </p:txBody>
+      </p:sp>
+      <p:sp>
+        <p:nvSpPr>
+          <p:cNvPr id="17" name="Shape 14"/>
+          <p:cNvSpPr/>
+          <p:nvPr/>
+        </p:nvSpPr>
+        <p:spPr>
+          <a:xfrm>
+            <a:off x="8046720" y="1737360"/>
+            <a:ext cx="182880" cy="1554480"/>
+          </a:xfrm>
+          <a:prstGeom prst="line">
+            <a:avLst/>
+          </a:prstGeom>
+          <a:noFill/>
+          <a:ln w="19050">
+            <a:solidFill>
+              <a:srgbClr val="E10098"/>
+            </a:solidFill>
+            <a:prstDash val="solid"/>
+          </a:ln>
+        </p:spPr>
+        <p:txBody>
+          <a:bodyPr/>
+          <a:lstStyle/>
+          <a:p>
+            <a:endParaRPr lang="es-AR"/>
+          </a:p>
+        </p:txBody>
+      </p:sp>
+      <p:sp>
+        <p:nvSpPr>
+          <p:cNvPr id="18" name="Shape 15"/>
+          <p:cNvSpPr/>
+          <p:nvPr/>
+        </p:nvSpPr>
+        <p:spPr>
+          <a:xfrm flipV="1">
+            <a:off x="6309360" y="2651760"/>
+            <a:ext cx="640080" cy="1280160"/>
+          </a:xfrm>
+          <a:prstGeom prst="line">
+            <a:avLst/>
+          </a:prstGeom>
+          <a:noFill/>
+          <a:ln w="19050">
+            <a:solidFill>
+              <a:srgbClr val="E10098"/>
+            </a:solidFill>
+            <a:prstDash val="solid"/>
+          </a:ln>
+        </p:spPr>
+        <p:txBody>
+          <a:bodyPr/>
+          <a:lstStyle/>
+          <a:p>
+            <a:endParaRPr lang="es-AR"/>
+          </a:p>
+        </p:txBody>
+      </p:sp>
+      <p:sp>
+        <p:nvSpPr>
+          <p:cNvPr id="19" name="Shape 16"/>
+          <p:cNvSpPr/>
+          <p:nvPr/>
+        </p:nvSpPr>
+        <p:spPr>
+          <a:xfrm>
+            <a:off x="6949440" y="2651760"/>
+            <a:ext cx="548640" cy="1463040"/>
+          </a:xfrm>
+          <a:prstGeom prst="line">
+            <a:avLst/>
+          </a:prstGeom>
+          <a:noFill/>
+          <a:ln w="19050">
+            <a:solidFill>
+              <a:srgbClr val="E10098"/>
+            </a:solidFill>
+            <a:prstDash val="solid"/>
+          </a:ln>
+        </p:spPr>
+        <p:txBody>
+          <a:bodyPr/>
+          <a:lstStyle/>
+          <a:p>
+            <a:endParaRPr lang="es-AR"/>
+          </a:p>
+        </p:txBody>
+      </p:sp>
+      <p:sp>
+        <p:nvSpPr>
+          <p:cNvPr id="20" name="Shape 17"/>
+          <p:cNvSpPr/>
+          <p:nvPr/>
+        </p:nvSpPr>
+        <p:spPr>
+          <a:xfrm flipV="1">
+            <a:off x="7498080" y="3291840"/>
+            <a:ext cx="731520" cy="822960"/>
+          </a:xfrm>
+          <a:prstGeom prst="line">
+            <a:avLst/>
+          </a:prstGeom>
+          <a:noFill/>
+          <a:ln w="19050">
+            <a:solidFill>
+              <a:srgbClr val="E10098"/>
+            </a:solidFill>
+            <a:prstDash val="solid"/>
+          </a:ln>
+        </p:spPr>
+        <p:txBody>
+          <a:bodyPr/>
+          <a:lstStyle/>
+          <a:p>
+            <a:endParaRPr lang="es-AR"/>
+          </a:p>
+        </p:txBody>
+      </p:sp>
+      <p:sp>
+        <p:nvSpPr>
+          <p:cNvPr id="21" name="Shape 18"/>
+          <p:cNvSpPr/>
+          <p:nvPr/>
+        </p:nvSpPr>
+        <p:spPr>
+          <a:xfrm>
+            <a:off x="6382512" y="987552"/>
+            <a:ext cx="402336" cy="402336"/>
+          </a:xfrm>
+          <a:prstGeom prst="ellipse">
+            <a:avLst/>
+          </a:prstGeom>
+          <a:solidFill>
+            <a:srgbClr val="E10098"/>
+          </a:solidFill>
+          <a:ln w="25400">
+            <a:solidFill>
+              <a:srgbClr val="E10098"/>
+            </a:solidFill>
+            <a:prstDash val="solid"/>
+          </a:ln>
+        </p:spPr>
+        <p:txBody>
+          <a:bodyPr/>
+          <a:lstStyle/>
+          <a:p>
+            <a:endParaRPr lang="es-AR"/>
+          </a:p>
+        </p:txBody>
+      </p:sp>
+      <p:sp>
+        <p:nvSpPr>
+          <p:cNvPr id="22" name="Shape 19"/>
+          <p:cNvSpPr/>
+          <p:nvPr/>
+        </p:nvSpPr>
+        <p:spPr>
+          <a:xfrm>
+            <a:off x="7845552" y="1536192"/>
+            <a:ext cx="402336" cy="402336"/>
+          </a:xfrm>
+          <a:prstGeom prst="ellipse">
+            <a:avLst/>
+          </a:prstGeom>
+          <a:solidFill>
+            <a:srgbClr val="FFFFFF"/>
+          </a:solidFill>
+          <a:ln w="25400">
+            <a:solidFill>
+              <a:srgbClr val="E10098"/>
+            </a:solidFill>
+            <a:prstDash val="solid"/>
+          </a:ln>
+        </p:spPr>
+        <p:txBody>
+          <a:bodyPr/>
+          <a:lstStyle/>
+          <a:p>
+            <a:endParaRPr lang="es-AR"/>
+          </a:p>
+        </p:txBody>
+      </p:sp>
+      <p:sp>
+        <p:nvSpPr>
+          <p:cNvPr id="23" name="Shape 20"/>
+          <p:cNvSpPr/>
+          <p:nvPr/>
+        </p:nvSpPr>
+        <p:spPr>
+          <a:xfrm>
+            <a:off x="6748272" y="2450592"/>
+            <a:ext cx="402336" cy="402336"/>
+          </a:xfrm>
+          <a:prstGeom prst="ellipse">
+            <a:avLst/>
+          </a:prstGeom>
+          <a:solidFill>
+            <a:srgbClr val="E10098"/>
+          </a:solidFill>
+          <a:ln w="25400">
+            <a:solidFill>
+              <a:srgbClr val="E10098"/>
+            </a:solidFill>
+            <a:prstDash val="solid"/>
+          </a:ln>
+        </p:spPr>
+        <p:txBody>
+          <a:bodyPr/>
+          <a:lstStyle/>
+          <a:p>
+            <a:endParaRPr lang="es-AR"/>
+          </a:p>
+        </p:txBody>
+      </p:sp>
+      <p:sp>
+        <p:nvSpPr>
+          <p:cNvPr id="24" name="Shape 21"/>
+          <p:cNvSpPr/>
+          <p:nvPr/>
+        </p:nvSpPr>
+        <p:spPr>
+          <a:xfrm>
+            <a:off x="8028432" y="3090672"/>
+            <a:ext cx="402336" cy="402336"/>
+          </a:xfrm>
+          <a:prstGeom prst="ellipse">
+            <a:avLst/>
+          </a:prstGeom>
+          <a:solidFill>
+            <a:srgbClr val="FFFFFF"/>
+          </a:solidFill>
+          <a:ln w="25400">
+            <a:solidFill>
+              <a:srgbClr val="E10098"/>
+            </a:solidFill>
+            <a:prstDash val="solid"/>
+          </a:ln>
+        </p:spPr>
+        <p:txBody>
+          <a:bodyPr/>
+          <a:lstStyle/>
+          <a:p>
+            <a:endParaRPr lang="es-AR"/>
+          </a:p>
+        </p:txBody>
+      </p:sp>
+      <p:sp>
+        <p:nvSpPr>
+          <p:cNvPr id="25" name="Shape 22"/>
+          <p:cNvSpPr/>
+          <p:nvPr/>
+        </p:nvSpPr>
+        <p:spPr>
+          <a:xfrm>
+            <a:off x="6108192" y="3730752"/>
+            <a:ext cx="402336" cy="402336"/>
+          </a:xfrm>
+          <a:prstGeom prst="ellipse">
+            <a:avLst/>
+          </a:prstGeom>
+          <a:solidFill>
+            <a:srgbClr val="E10098"/>
+          </a:solidFill>
+          <a:ln w="25400">
+            <a:solidFill>
+              <a:srgbClr val="E10098"/>
+            </a:solidFill>
+            <a:prstDash val="solid"/>
+          </a:ln>
+        </p:spPr>
+        <p:txBody>
+          <a:bodyPr/>
+          <a:lstStyle/>
+          <a:p>
+            <a:endParaRPr lang="es-AR"/>
+          </a:p>
+        </p:txBody>
+      </p:sp>
+      <p:sp>
+        <p:nvSpPr>
+          <p:cNvPr id="26" name="Shape 23"/>
+          <p:cNvSpPr/>
+          <p:nvPr/>
+        </p:nvSpPr>
+        <p:spPr>
+          <a:xfrm>
+            <a:off x="7296912" y="3913632"/>
+            <a:ext cx="402336" cy="402336"/>
+          </a:xfrm>
+          <a:prstGeom prst="ellipse">
+            <a:avLst/>
+          </a:prstGeom>
+          <a:solidFill>
+            <a:srgbClr val="FFFFFF"/>
+          </a:solidFill>
+          <a:ln w="25400">
+            <a:solidFill>
+              <a:srgbClr val="E10098"/>
+            </a:solidFill>
+            <a:prstDash val="solid"/>
+          </a:ln>
+        </p:spPr>
+        <p:txBody>
+          <a:bodyPr/>
+          <a:lstStyle/>
+          <a:p>
+            <a:endParaRPr lang="es-AR"/>
+          </a:p>
+        </p:txBody>
+      </p:sp>
+    </p:spTree>
+  </p:cSld>
+  <p:clrMapOvr>
+    <a:masterClrMapping/>
+  </p:clrMapOvr>
+</p:sld>
+</file>
+
 <file path=ppt/slides/slide2.xml><?xml version="1.0" encoding="utf-8"?>
 <p:sld xmlns:a="http://schemas.openxmlformats.org/drawingml/2006/main" xmlns:r="http://schemas.openxmlformats.org/officeDocument/2006/relationships" xmlns:p="http://schemas.openxmlformats.org/presentationml/2006/main">
   <p:cSld name="Slide 2">
@@ -2270,7 +2838,7 @@
                 <a:ea typeface="Calibri" pitchFamily="34" charset="-122"/>
                 <a:cs typeface="Calibri" pitchFamily="34" charset="-120"/>
               </a:rPr>
-              <a:t>2</a:t>
+              <a:t>3</a:t>
             </a:r>
             <a:endParaRPr lang="en-US" sz="900" dirty="0"/>
           </a:p>
@@ -2963,7 +3531,7 @@
                 <a:ea typeface="Calibri" pitchFamily="34" charset="-122"/>
                 <a:cs typeface="Calibri" pitchFamily="34" charset="-120"/>
               </a:rPr>
-              <a:t>3</a:t>
+              <a:t>4</a:t>
             </a:r>
             <a:endParaRPr lang="en-US" sz="900" dirty="0"/>
           </a:p>
@@ -3766,7 +4334,7 @@
                 <a:ea typeface="Calibri" pitchFamily="34" charset="-122"/>
                 <a:cs typeface="Calibri" pitchFamily="34" charset="-120"/>
               </a:rPr>
-              <a:t>4</a:t>
+              <a:t>5</a:t>
             </a:r>
             <a:endParaRPr lang="en-US" sz="900" dirty="0"/>
           </a:p>
@@ -4924,7 +5492,7 @@
                 <a:ea typeface="Calibri" pitchFamily="34" charset="-122"/>
                 <a:cs typeface="Calibri" pitchFamily="34" charset="-120"/>
               </a:rPr>
-              <a:t>5</a:t>
+              <a:t>6</a:t>
             </a:r>
             <a:endParaRPr lang="en-US" sz="900" dirty="0"/>
           </a:p>
@@ -5941,7 +6509,7 @@
                 <a:ea typeface="Calibri" pitchFamily="34" charset="-122"/>
                 <a:cs typeface="Calibri" pitchFamily="34" charset="-120"/>
               </a:rPr>
-              <a:t>6</a:t>
+              <a:t>7</a:t>
             </a:r>
             <a:endParaRPr lang="en-US" sz="900" dirty="0"/>
           </a:p>
@@ -6578,7 +7146,7 @@
                 <a:ea typeface="Calibri" pitchFamily="34" charset="-122"/>
                 <a:cs typeface="Calibri" pitchFamily="34" charset="-120"/>
               </a:rPr>
-              <a:t>7</a:t>
+              <a:t>8</a:t>
             </a:r>
             <a:endParaRPr lang="en-US" sz="900" dirty="0"/>
           </a:p>
@@ -7987,7 +8555,7 @@
                 <a:ea typeface="Calibri" pitchFamily="34" charset="-122"/>
                 <a:cs typeface="Calibri" pitchFamily="34" charset="-120"/>
               </a:rPr>
-              <a:t>8</a:t>
+              <a:t>9</a:t>
             </a:r>
             <a:endParaRPr lang="en-US" sz="900" dirty="0"/>
           </a:p>
@@ -8611,6 +9179,859 @@
               <a:t>GraphQL no reemplaza a REST: resuelve un problema puntual.</a:t>
             </a:r>
             <a:endParaRPr lang="en-US" sz="1800" dirty="0"/>
+          </a:p>
+        </p:txBody>
+      </p:sp>
+    </p:spTree>
+  </p:cSld>
+  <p:clrMapOvr>
+    <a:masterClrMapping/>
+  </p:clrMapOvr>
+</p:sld>
+</file>
+
+<file path=ppt/slides/slide9.xml><?xml version="1.0" encoding="utf-8"?>
+<p:sld xmlns:a="http://schemas.openxmlformats.org/drawingml/2006/main" xmlns:r="http://schemas.openxmlformats.org/officeDocument/2006/relationships" xmlns:p="http://schemas.openxmlformats.org/presentationml/2006/main">
+  <p:cSld name="Slide 2">
+    <p:bg>
+      <p:bgPr>
+        <a:solidFill>
+          <a:srgbClr val="FFFFFF"/>
+        </a:solidFill>
+        <a:effectLst/>
+      </p:bgPr>
+    </p:bg>
+    <p:spTree>
+      <p:nvGrpSpPr>
+        <p:cNvPr id="1" name=""/>
+        <p:cNvGrpSpPr/>
+        <p:nvPr/>
+      </p:nvGrpSpPr>
+      <p:grpSpPr>
+        <a:xfrm>
+          <a:off x="0" y="0"/>
+          <a:ext cx="0" cy="0"/>
+          <a:chOff x="0" y="0"/>
+          <a:chExt cx="0" cy="0"/>
+        </a:xfrm>
+      </p:grpSpPr>
+      <p:sp>
+        <p:nvSpPr>
+          <p:cNvPr id="101" name="Text 101"/>
+          <p:cNvSpPr txBox="1"/>
+          <p:nvPr/>
+        </p:nvSpPr>
+        <p:spPr>
+          <a:xfrm>
+            <a:off x="457200" y="274320"/>
+            <a:ext cx="8229600" cy="685800"/>
+          </a:xfrm>
+          <a:prstGeom prst="rect">
+            <a:avLst/>
+          </a:prstGeom>
+          <a:noFill/>
+          <a:ln/>
+        </p:spPr>
+        <p:txBody>
+          <a:bodyPr wrap="square" lIns="0" tIns="0" rIns="0" bIns="0" rtlCol="0" anchor="ctr"/>
+          <a:lstStyle/>
+          <a:p>
+            <a:pPr marL="0" indent="0">
+              <a:buNone/>
+            </a:pPr>
+            <a:r>
+              <a:rPr lang="es-AR" sz="3200" b="1" dirty="0">
+                <a:solidFill>
+                  <a:srgbClr val="1B1F3B"/>
+                </a:solidFill>
+                <a:latin typeface="Cambria" pitchFamily="34" charset="0"/>
+                <a:ea typeface="Cambria" pitchFamily="34" charset="-122"/>
+                <a:cs typeface="Cambria" pitchFamily="34" charset="-120"/>
+              </a:rPr>
+              <a:t>Un poco de historia</a:t>
+            </a:r>
+          </a:p>
+        </p:txBody>
+      </p:sp>
+      <p:sp>
+        <p:nvSpPr>
+          <p:cNvPr id="102" name="Text 102"/>
+          <p:cNvSpPr txBox="1"/>
+          <p:nvPr/>
+        </p:nvSpPr>
+        <p:spPr>
+          <a:xfrm>
+            <a:off x="457200" y="1051560"/>
+            <a:ext cx="8229600" cy="548640"/>
+          </a:xfrm>
+          <a:prstGeom prst="rect">
+            <a:avLst/>
+          </a:prstGeom>
+          <a:noFill/>
+          <a:ln/>
+        </p:spPr>
+        <p:txBody>
+          <a:bodyPr wrap="square" lIns="0" tIns="0" rIns="0" bIns="0" rtlCol="0" anchor="ctr"/>
+          <a:lstStyle/>
+          <a:p>
+            <a:pPr marL="0" indent="0">
+              <a:buNone/>
+            </a:pPr>
+            <a:r>
+              <a:rPr lang="es-AR" sz="2000" dirty="0">
+                <a:solidFill>
+                  <a:srgbClr val="1B1F3B"/>
+                </a:solidFill>
+                <a:latin typeface="Calibri" pitchFamily="34" charset="0"/>
+                <a:ea typeface="Calibri" pitchFamily="34" charset="-122"/>
+                <a:cs typeface="Calibri" pitchFamily="34" charset="-120"/>
+              </a:rPr>
+              <a:t>Creado por Facebook en 2012 y liberado como código abierto en 2015.</a:t>
+            </a:r>
+          </a:p>
+        </p:txBody>
+      </p:sp>
+      <p:sp>
+        <p:nvSpPr>
+          <p:cNvPr id="103" name="Card 103"/>
+          <p:cNvSpPr/>
+          <p:nvPr/>
+        </p:nvSpPr>
+        <p:spPr>
+          <a:xfrm>
+            <a:off x="457200" y="1783080"/>
+            <a:ext cx="1920240" cy="1828800"/>
+          </a:xfrm>
+          <a:prstGeom prst="roundRect">
+            <a:avLst>
+              <a:gd name="adj" fmla="val 5000"/>
+            </a:avLst>
+          </a:prstGeom>
+          <a:solidFill>
+            <a:srgbClr val="F6EEF6"/>
+          </a:solidFill>
+          <a:ln w="9525">
+            <a:solidFill>
+              <a:srgbClr val="E3D6E3"/>
+            </a:solidFill>
+          </a:ln>
+        </p:spPr>
+        <p:txBody>
+          <a:bodyPr/>
+          <a:lstStyle/>
+          <a:p>
+            <a:endParaRPr lang="es-AR"/>
+          </a:p>
+        </p:txBody>
+      </p:sp>
+      <p:sp>
+        <p:nvSpPr>
+          <p:cNvPr id="104" name="Text 104"/>
+          <p:cNvSpPr txBox="1"/>
+          <p:nvPr/>
+        </p:nvSpPr>
+        <p:spPr>
+          <a:xfrm>
+            <a:off x="640080" y="1920240"/>
+            <a:ext cx="1554480" cy="411480"/>
+          </a:xfrm>
+          <a:prstGeom prst="rect">
+            <a:avLst/>
+          </a:prstGeom>
+          <a:noFill/>
+          <a:ln/>
+        </p:spPr>
+        <p:txBody>
+          <a:bodyPr wrap="square" lIns="0" tIns="0" rIns="0" bIns="0" rtlCol="0" anchor="ctr"/>
+          <a:lstStyle/>
+          <a:p>
+            <a:pPr marL="0" indent="0">
+              <a:buNone/>
+            </a:pPr>
+            <a:r>
+              <a:rPr lang="es-AR" sz="2800" b="1" dirty="0">
+                <a:solidFill>
+                  <a:srgbClr val="E10098"/>
+                </a:solidFill>
+                <a:latin typeface="Cambria" pitchFamily="34" charset="0"/>
+                <a:ea typeface="Cambria" pitchFamily="34" charset="-122"/>
+                <a:cs typeface="Cambria" pitchFamily="34" charset="-120"/>
+              </a:rPr>
+              <a:t>2012</a:t>
+            </a:r>
+          </a:p>
+        </p:txBody>
+      </p:sp>
+      <p:sp>
+        <p:nvSpPr>
+          <p:cNvPr id="105" name="Text 105"/>
+          <p:cNvSpPr txBox="1"/>
+          <p:nvPr/>
+        </p:nvSpPr>
+        <p:spPr>
+          <a:xfrm>
+            <a:off x="640080" y="2377440"/>
+            <a:ext cx="1554480" cy="274320"/>
+          </a:xfrm>
+          <a:prstGeom prst="rect">
+            <a:avLst/>
+          </a:prstGeom>
+          <a:noFill/>
+          <a:ln/>
+        </p:spPr>
+        <p:txBody>
+          <a:bodyPr wrap="square" lIns="0" tIns="0" rIns="0" bIns="0" rtlCol="0" anchor="ctr"/>
+          <a:lstStyle/>
+          <a:p>
+            <a:pPr marL="0" indent="0">
+              <a:buNone/>
+            </a:pPr>
+            <a:r>
+              <a:rPr lang="es-AR" sz="1400" b="1" dirty="0">
+                <a:solidFill>
+                  <a:srgbClr val="1B1F3B"/>
+                </a:solidFill>
+                <a:latin typeface="Cambria" pitchFamily="34" charset="0"/>
+                <a:ea typeface="Cambria" pitchFamily="34" charset="-122"/>
+                <a:cs typeface="Cambria" pitchFamily="34" charset="-120"/>
+              </a:rPr>
+              <a:t>Nace en Facebook</a:t>
+            </a:r>
+          </a:p>
+        </p:txBody>
+      </p:sp>
+      <p:sp>
+        <p:nvSpPr>
+          <p:cNvPr id="106" name="Text 106"/>
+          <p:cNvSpPr txBox="1"/>
+          <p:nvPr/>
+        </p:nvSpPr>
+        <p:spPr>
+          <a:xfrm>
+            <a:off x="640080" y="2743200"/>
+            <a:ext cx="1554480" cy="777240"/>
+          </a:xfrm>
+          <a:prstGeom prst="rect">
+            <a:avLst/>
+          </a:prstGeom>
+          <a:noFill/>
+          <a:ln/>
+        </p:spPr>
+        <p:txBody>
+          <a:bodyPr wrap="square" lIns="0" tIns="0" rIns="0" bIns="0" rtlCol="0" anchor="t"/>
+          <a:lstStyle/>
+          <a:p>
+            <a:pPr marL="0" indent="0">
+              <a:buNone/>
+            </a:pPr>
+            <a:r>
+              <a:rPr lang="es-AR" sz="1200" dirty="0">
+                <a:solidFill>
+                  <a:srgbClr val="5B6178"/>
+                </a:solidFill>
+                <a:latin typeface="Calibri" pitchFamily="34" charset="0"/>
+                <a:ea typeface="Calibri" pitchFamily="34" charset="-122"/>
+                <a:cs typeface="Calibri" pitchFamily="34" charset="-120"/>
+              </a:rPr>
+              <a:t>La app de iOS pasa a ser nativa y el News Feed necesita datos anidados en pocas llamadas.</a:t>
+            </a:r>
+          </a:p>
+        </p:txBody>
+      </p:sp>
+      <p:sp>
+        <p:nvSpPr>
+          <p:cNvPr id="107" name="Card 107"/>
+          <p:cNvSpPr/>
+          <p:nvPr/>
+        </p:nvSpPr>
+        <p:spPr>
+          <a:xfrm>
+            <a:off x="2560320" y="1783080"/>
+            <a:ext cx="1920240" cy="1828800"/>
+          </a:xfrm>
+          <a:prstGeom prst="roundRect">
+            <a:avLst>
+              <a:gd name="adj" fmla="val 5000"/>
+            </a:avLst>
+          </a:prstGeom>
+          <a:solidFill>
+            <a:srgbClr val="F6EEF6"/>
+          </a:solidFill>
+          <a:ln w="9525">
+            <a:solidFill>
+              <a:srgbClr val="E3D6E3"/>
+            </a:solidFill>
+          </a:ln>
+        </p:spPr>
+        <p:txBody>
+          <a:bodyPr/>
+          <a:lstStyle/>
+          <a:p>
+            <a:endParaRPr lang="es-AR"/>
+          </a:p>
+        </p:txBody>
+      </p:sp>
+      <p:sp>
+        <p:nvSpPr>
+          <p:cNvPr id="108" name="Text 108"/>
+          <p:cNvSpPr txBox="1"/>
+          <p:nvPr/>
+        </p:nvSpPr>
+        <p:spPr>
+          <a:xfrm>
+            <a:off x="2743200" y="1920240"/>
+            <a:ext cx="1554480" cy="411480"/>
+          </a:xfrm>
+          <a:prstGeom prst="rect">
+            <a:avLst/>
+          </a:prstGeom>
+          <a:noFill/>
+          <a:ln/>
+        </p:spPr>
+        <p:txBody>
+          <a:bodyPr wrap="square" lIns="0" tIns="0" rIns="0" bIns="0" rtlCol="0" anchor="ctr"/>
+          <a:lstStyle/>
+          <a:p>
+            <a:pPr marL="0" indent="0">
+              <a:buNone/>
+            </a:pPr>
+            <a:r>
+              <a:rPr lang="es-AR" sz="2800" b="1" dirty="0">
+                <a:solidFill>
+                  <a:srgbClr val="E10098"/>
+                </a:solidFill>
+                <a:latin typeface="Cambria" pitchFamily="34" charset="0"/>
+                <a:ea typeface="Cambria" pitchFamily="34" charset="-122"/>
+                <a:cs typeface="Cambria" pitchFamily="34" charset="-120"/>
+              </a:rPr>
+              <a:t>2015</a:t>
+            </a:r>
+          </a:p>
+        </p:txBody>
+      </p:sp>
+      <p:sp>
+        <p:nvSpPr>
+          <p:cNvPr id="109" name="Text 109"/>
+          <p:cNvSpPr txBox="1"/>
+          <p:nvPr/>
+        </p:nvSpPr>
+        <p:spPr>
+          <a:xfrm>
+            <a:off x="2743200" y="2377440"/>
+            <a:ext cx="1554480" cy="274320"/>
+          </a:xfrm>
+          <a:prstGeom prst="rect">
+            <a:avLst/>
+          </a:prstGeom>
+          <a:noFill/>
+          <a:ln/>
+        </p:spPr>
+        <p:txBody>
+          <a:bodyPr wrap="square" lIns="0" tIns="0" rIns="0" bIns="0" rtlCol="0" anchor="ctr"/>
+          <a:lstStyle/>
+          <a:p>
+            <a:pPr marL="0" indent="0">
+              <a:buNone/>
+            </a:pPr>
+            <a:r>
+              <a:rPr lang="es-AR" sz="1400" b="1" dirty="0">
+                <a:solidFill>
+                  <a:srgbClr val="1B1F3B"/>
+                </a:solidFill>
+                <a:latin typeface="Cambria" pitchFamily="34" charset="0"/>
+                <a:ea typeface="Cambria" pitchFamily="34" charset="-122"/>
+                <a:cs typeface="Cambria" pitchFamily="34" charset="-120"/>
+              </a:rPr>
+              <a:t>Código abierto</a:t>
+            </a:r>
+          </a:p>
+        </p:txBody>
+      </p:sp>
+      <p:sp>
+        <p:nvSpPr>
+          <p:cNvPr id="110" name="Text 110"/>
+          <p:cNvSpPr txBox="1"/>
+          <p:nvPr/>
+        </p:nvSpPr>
+        <p:spPr>
+          <a:xfrm>
+            <a:off x="2743200" y="2743200"/>
+            <a:ext cx="1554480" cy="777240"/>
+          </a:xfrm>
+          <a:prstGeom prst="rect">
+            <a:avLst/>
+          </a:prstGeom>
+          <a:noFill/>
+          <a:ln/>
+        </p:spPr>
+        <p:txBody>
+          <a:bodyPr wrap="square" lIns="0" tIns="0" rIns="0" bIns="0" rtlCol="0" anchor="t"/>
+          <a:lstStyle/>
+          <a:p>
+            <a:pPr marL="0" indent="0">
+              <a:buNone/>
+            </a:pPr>
+            <a:r>
+              <a:rPr lang="es-AR" sz="1200" dirty="0">
+                <a:solidFill>
+                  <a:srgbClr val="5B6178"/>
+                </a:solidFill>
+                <a:latin typeface="Calibri" pitchFamily="34" charset="0"/>
+                <a:ea typeface="Calibri" pitchFamily="34" charset="-122"/>
+                <a:cs typeface="Calibri" pitchFamily="34" charset="-120"/>
+              </a:rPr>
+              <a:t>Facebook publica la especificación y la implementación de referencia, graphql-js.</a:t>
+            </a:r>
+          </a:p>
+        </p:txBody>
+      </p:sp>
+      <p:sp>
+        <p:nvSpPr>
+          <p:cNvPr id="111" name="Card 111"/>
+          <p:cNvSpPr/>
+          <p:nvPr/>
+        </p:nvSpPr>
+        <p:spPr>
+          <a:xfrm>
+            <a:off x="4663440" y="1783080"/>
+            <a:ext cx="1920240" cy="1828800"/>
+          </a:xfrm>
+          <a:prstGeom prst="roundRect">
+            <a:avLst>
+              <a:gd name="adj" fmla="val 5000"/>
+            </a:avLst>
+          </a:prstGeom>
+          <a:solidFill>
+            <a:srgbClr val="F6EEF6"/>
+          </a:solidFill>
+          <a:ln w="9525">
+            <a:solidFill>
+              <a:srgbClr val="E3D6E3"/>
+            </a:solidFill>
+          </a:ln>
+        </p:spPr>
+        <p:txBody>
+          <a:bodyPr/>
+          <a:lstStyle/>
+          <a:p>
+            <a:endParaRPr lang="es-AR"/>
+          </a:p>
+        </p:txBody>
+      </p:sp>
+      <p:sp>
+        <p:nvSpPr>
+          <p:cNvPr id="112" name="Text 112"/>
+          <p:cNvSpPr txBox="1"/>
+          <p:nvPr/>
+        </p:nvSpPr>
+        <p:spPr>
+          <a:xfrm>
+            <a:off x="4846320" y="1920240"/>
+            <a:ext cx="1554480" cy="411480"/>
+          </a:xfrm>
+          <a:prstGeom prst="rect">
+            <a:avLst/>
+          </a:prstGeom>
+          <a:noFill/>
+          <a:ln/>
+        </p:spPr>
+        <p:txBody>
+          <a:bodyPr wrap="square" lIns="0" tIns="0" rIns="0" bIns="0" rtlCol="0" anchor="ctr"/>
+          <a:lstStyle/>
+          <a:p>
+            <a:pPr marL="0" indent="0">
+              <a:buNone/>
+            </a:pPr>
+            <a:r>
+              <a:rPr lang="es-AR" sz="2800" b="1" dirty="0">
+                <a:solidFill>
+                  <a:srgbClr val="E10098"/>
+                </a:solidFill>
+                <a:latin typeface="Cambria" pitchFamily="34" charset="0"/>
+                <a:ea typeface="Cambria" pitchFamily="34" charset="-122"/>
+                <a:cs typeface="Cambria" pitchFamily="34" charset="-120"/>
+              </a:rPr>
+              <a:t>2016</a:t>
+            </a:r>
+          </a:p>
+        </p:txBody>
+      </p:sp>
+      <p:sp>
+        <p:nvSpPr>
+          <p:cNvPr id="113" name="Text 113"/>
+          <p:cNvSpPr txBox="1"/>
+          <p:nvPr/>
+        </p:nvSpPr>
+        <p:spPr>
+          <a:xfrm>
+            <a:off x="4846320" y="2377440"/>
+            <a:ext cx="1554480" cy="274320"/>
+          </a:xfrm>
+          <a:prstGeom prst="rect">
+            <a:avLst/>
+          </a:prstGeom>
+          <a:noFill/>
+          <a:ln/>
+        </p:spPr>
+        <p:txBody>
+          <a:bodyPr wrap="square" lIns="0" tIns="0" rIns="0" bIns="0" rtlCol="0" anchor="ctr"/>
+          <a:lstStyle/>
+          <a:p>
+            <a:pPr marL="0" indent="0">
+              <a:buNone/>
+            </a:pPr>
+            <a:r>
+              <a:rPr lang="es-AR" sz="1400" b="1" dirty="0">
+                <a:solidFill>
+                  <a:srgbClr val="1B1F3B"/>
+                </a:solidFill>
+                <a:latin typeface="Cambria" pitchFamily="34" charset="0"/>
+                <a:ea typeface="Cambria" pitchFamily="34" charset="-122"/>
+                <a:cs typeface="Cambria" pitchFamily="34" charset="-120"/>
+              </a:rPr>
+              <a:t>Llega a la industria</a:t>
+            </a:r>
+          </a:p>
+        </p:txBody>
+      </p:sp>
+      <p:sp>
+        <p:nvSpPr>
+          <p:cNvPr id="114" name="Text 114"/>
+          <p:cNvSpPr txBox="1"/>
+          <p:nvPr/>
+        </p:nvSpPr>
+        <p:spPr>
+          <a:xfrm>
+            <a:off x="4846320" y="2743200"/>
+            <a:ext cx="1554480" cy="777240"/>
+          </a:xfrm>
+          <a:prstGeom prst="rect">
+            <a:avLst/>
+          </a:prstGeom>
+          <a:noFill/>
+          <a:ln/>
+        </p:spPr>
+        <p:txBody>
+          <a:bodyPr wrap="square" lIns="0" tIns="0" rIns="0" bIns="0" rtlCol="0" anchor="t"/>
+          <a:lstStyle/>
+          <a:p>
+            <a:pPr marL="0" indent="0">
+              <a:buNone/>
+            </a:pPr>
+            <a:r>
+              <a:rPr lang="es-AR" sz="1200" dirty="0">
+                <a:solidFill>
+                  <a:srgbClr val="5B6178"/>
+                </a:solidFill>
+                <a:latin typeface="Calibri" pitchFamily="34" charset="0"/>
+                <a:ea typeface="Calibri" pitchFamily="34" charset="-122"/>
+                <a:cs typeface="Calibri" pitchFamily="34" charset="-120"/>
+              </a:rPr>
+              <a:t>GitHub lanza su API v4 en GraphQL; le siguen Shopify, Netflix y otros.</a:t>
+            </a:r>
+          </a:p>
+        </p:txBody>
+      </p:sp>
+      <p:sp>
+        <p:nvSpPr>
+          <p:cNvPr id="115" name="Card 115"/>
+          <p:cNvSpPr/>
+          <p:nvPr/>
+        </p:nvSpPr>
+        <p:spPr>
+          <a:xfrm>
+            <a:off x="6766560" y="1783080"/>
+            <a:ext cx="1920240" cy="1828800"/>
+          </a:xfrm>
+          <a:prstGeom prst="roundRect">
+            <a:avLst>
+              <a:gd name="adj" fmla="val 5000"/>
+            </a:avLst>
+          </a:prstGeom>
+          <a:solidFill>
+            <a:srgbClr val="F6EEF6"/>
+          </a:solidFill>
+          <a:ln w="9525">
+            <a:solidFill>
+              <a:srgbClr val="E3D6E3"/>
+            </a:solidFill>
+          </a:ln>
+        </p:spPr>
+        <p:txBody>
+          <a:bodyPr/>
+          <a:lstStyle/>
+          <a:p>
+            <a:endParaRPr lang="es-AR"/>
+          </a:p>
+        </p:txBody>
+      </p:sp>
+      <p:sp>
+        <p:nvSpPr>
+          <p:cNvPr id="116" name="Text 116"/>
+          <p:cNvSpPr txBox="1"/>
+          <p:nvPr/>
+        </p:nvSpPr>
+        <p:spPr>
+          <a:xfrm>
+            <a:off x="6949440" y="1920240"/>
+            <a:ext cx="1554480" cy="411480"/>
+          </a:xfrm>
+          <a:prstGeom prst="rect">
+            <a:avLst/>
+          </a:prstGeom>
+          <a:noFill/>
+          <a:ln/>
+        </p:spPr>
+        <p:txBody>
+          <a:bodyPr wrap="square" lIns="0" tIns="0" rIns="0" bIns="0" rtlCol="0" anchor="ctr"/>
+          <a:lstStyle/>
+          <a:p>
+            <a:pPr marL="0" indent="0">
+              <a:buNone/>
+            </a:pPr>
+            <a:r>
+              <a:rPr lang="es-AR" sz="2800" b="1" dirty="0">
+                <a:solidFill>
+                  <a:srgbClr val="E10098"/>
+                </a:solidFill>
+                <a:latin typeface="Cambria" pitchFamily="34" charset="0"/>
+                <a:ea typeface="Cambria" pitchFamily="34" charset="-122"/>
+                <a:cs typeface="Cambria" pitchFamily="34" charset="-120"/>
+              </a:rPr>
+              <a:t>2018</a:t>
+            </a:r>
+          </a:p>
+        </p:txBody>
+      </p:sp>
+      <p:sp>
+        <p:nvSpPr>
+          <p:cNvPr id="117" name="Text 117"/>
+          <p:cNvSpPr txBox="1"/>
+          <p:nvPr/>
+        </p:nvSpPr>
+        <p:spPr>
+          <a:xfrm>
+            <a:off x="6949440" y="2377440"/>
+            <a:ext cx="1554480" cy="274320"/>
+          </a:xfrm>
+          <a:prstGeom prst="rect">
+            <a:avLst/>
+          </a:prstGeom>
+          <a:noFill/>
+          <a:ln/>
+        </p:spPr>
+        <p:txBody>
+          <a:bodyPr wrap="square" lIns="0" tIns="0" rIns="0" bIns="0" rtlCol="0" anchor="ctr"/>
+          <a:lstStyle/>
+          <a:p>
+            <a:pPr marL="0" indent="0">
+              <a:buNone/>
+            </a:pPr>
+            <a:r>
+              <a:rPr lang="es-AR" sz="1400" b="1" dirty="0">
+                <a:solidFill>
+                  <a:srgbClr val="1B1F3B"/>
+                </a:solidFill>
+                <a:latin typeface="Cambria" pitchFamily="34" charset="0"/>
+                <a:ea typeface="Cambria" pitchFamily="34" charset="-122"/>
+                <a:cs typeface="Cambria" pitchFamily="34" charset="-120"/>
+              </a:rPr>
+              <a:t>Fundación propia</a:t>
+            </a:r>
+          </a:p>
+        </p:txBody>
+      </p:sp>
+      <p:sp>
+        <p:nvSpPr>
+          <p:cNvPr id="118" name="Text 118"/>
+          <p:cNvSpPr txBox="1"/>
+          <p:nvPr/>
+        </p:nvSpPr>
+        <p:spPr>
+          <a:xfrm>
+            <a:off x="6949440" y="2743200"/>
+            <a:ext cx="1554480" cy="777240"/>
+          </a:xfrm>
+          <a:prstGeom prst="rect">
+            <a:avLst/>
+          </a:prstGeom>
+          <a:noFill/>
+          <a:ln/>
+        </p:spPr>
+        <p:txBody>
+          <a:bodyPr wrap="square" lIns="0" tIns="0" rIns="0" bIns="0" rtlCol="0" anchor="t"/>
+          <a:lstStyle/>
+          <a:p>
+            <a:pPr marL="0" indent="0">
+              <a:buNone/>
+            </a:pPr>
+            <a:r>
+              <a:rPr lang="es-AR" sz="1200" dirty="0">
+                <a:solidFill>
+                  <a:srgbClr val="5B6178"/>
+                </a:solidFill>
+                <a:latin typeface="Calibri" pitchFamily="34" charset="0"/>
+                <a:ea typeface="Calibri" pitchFamily="34" charset="-122"/>
+                <a:cs typeface="Calibri" pitchFamily="34" charset="-120"/>
+              </a:rPr>
+              <a:t>Pasa a la GraphQL Foundation, dentro de la Linux Foundation.</a:t>
+            </a:r>
+          </a:p>
+        </p:txBody>
+      </p:sp>
+      <p:sp>
+        <p:nvSpPr>
+          <p:cNvPr id="119" name="Banner 119"/>
+          <p:cNvSpPr/>
+          <p:nvPr/>
+        </p:nvSpPr>
+        <p:spPr>
+          <a:xfrm>
+            <a:off x="457200" y="3749040"/>
+            <a:ext cx="8229600" cy="822960"/>
+          </a:xfrm>
+          <a:prstGeom prst="roundRect">
+            <a:avLst>
+              <a:gd name="adj" fmla="val 12500"/>
+            </a:avLst>
+          </a:prstGeom>
+          <a:solidFill>
+            <a:srgbClr val="E10098"/>
+          </a:solidFill>
+          <a:ln>
+            <a:noFill/>
+          </a:ln>
+        </p:spPr>
+        <p:txBody>
+          <a:bodyPr/>
+          <a:lstStyle/>
+          <a:p>
+            <a:endParaRPr lang="es-AR"/>
+          </a:p>
+        </p:txBody>
+      </p:sp>
+      <p:sp>
+        <p:nvSpPr>
+          <p:cNvPr id="120" name="Text 120"/>
+          <p:cNvSpPr txBox="1"/>
+          <p:nvPr/>
+        </p:nvSpPr>
+        <p:spPr>
+          <a:xfrm>
+            <a:off x="640080" y="3817620"/>
+            <a:ext cx="7863840" cy="685800"/>
+          </a:xfrm>
+          <a:prstGeom prst="rect">
+            <a:avLst/>
+          </a:prstGeom>
+          <a:noFill/>
+          <a:ln/>
+        </p:spPr>
+        <p:txBody>
+          <a:bodyPr wrap="square" lIns="0" tIns="0" rIns="0" bIns="0" rtlCol="0" anchor="ctr"/>
+          <a:lstStyle/>
+          <a:p>
+            <a:pPr marL="0" indent="0">
+              <a:buNone/>
+            </a:pPr>
+            <a:r>
+              <a:rPr lang="es-AR" sz="1400" b="1" dirty="0">
+                <a:solidFill>
+                  <a:srgbClr val="FFFFFF"/>
+                </a:solidFill>
+                <a:latin typeface="Cambria" pitchFamily="34" charset="0"/>
+                <a:ea typeface="Cambria" pitchFamily="34" charset="-122"/>
+                <a:cs typeface="Cambria" pitchFamily="34" charset="-120"/>
+              </a:rPr>
+              <a:t>¿Por qué se creó? </a:t>
+            </a:r>
+            <a:r>
+              <a:rPr lang="es-AR" sz="1400" dirty="0">
+                <a:solidFill>
+                  <a:srgbClr val="FFFFFF"/>
+                </a:solidFill>
+                <a:latin typeface="Calibri" pitchFamily="34" charset="0"/>
+                <a:ea typeface="Calibri" pitchFamily="34" charset="-122"/>
+                <a:cs typeface="Calibri" pitchFamily="34" charset="-120"/>
+              </a:rPr>
+              <a:t>Con REST, cada pantalla del celular hacía varias llamadas y recibía datos de más, sobre redes móviles lentas. GraphQL deja que la pantalla pida justo lo que necesita, en una sola llamada.</a:t>
+            </a:r>
+          </a:p>
+        </p:txBody>
+      </p:sp>
+      <p:sp>
+        <p:nvSpPr>
+          <p:cNvPr id="121" name="Text 121"/>
+          <p:cNvSpPr txBox="1"/>
+          <p:nvPr/>
+        </p:nvSpPr>
+        <p:spPr>
+          <a:xfrm>
+            <a:off x="457200" y="4754880"/>
+            <a:ext cx="5486400" cy="228600"/>
+          </a:xfrm>
+          <a:prstGeom prst="rect">
+            <a:avLst/>
+          </a:prstGeom>
+          <a:noFill/>
+          <a:ln/>
+        </p:spPr>
+        <p:txBody>
+          <a:bodyPr wrap="square" lIns="0" tIns="0" rIns="0" bIns="0" rtlCol="0" anchor="ctr"/>
+          <a:lstStyle/>
+          <a:p>
+            <a:pPr marL="0" indent="0">
+              <a:buNone/>
+            </a:pPr>
+            <a:r>
+              <a:rPr lang="es-AR" sz="900" dirty="0">
+                <a:solidFill>
+                  <a:srgbClr val="5B6178"/>
+                </a:solidFill>
+                <a:latin typeface="Calibri" pitchFamily="34" charset="0"/>
+                <a:ea typeface="Calibri" pitchFamily="34" charset="-122"/>
+                <a:cs typeface="Calibri" pitchFamily="34" charset="-120"/>
+              </a:rPr>
+              <a:t>GraphQL y REST · Gamba y Milanesi · 2026</a:t>
+            </a:r>
+          </a:p>
+        </p:txBody>
+      </p:sp>
+      <p:sp>
+        <p:nvSpPr>
+          <p:cNvPr id="122" name="Text 122"/>
+          <p:cNvSpPr txBox="1"/>
+          <p:nvPr/>
+        </p:nvSpPr>
+        <p:spPr>
+          <a:xfrm>
+            <a:off x="8229600" y="4754880"/>
+            <a:ext cx="457200" cy="228600"/>
+          </a:xfrm>
+          <a:prstGeom prst="rect">
+            <a:avLst/>
+          </a:prstGeom>
+          <a:noFill/>
+          <a:ln/>
+        </p:spPr>
+        <p:txBody>
+          <a:bodyPr wrap="square" lIns="0" tIns="0" rIns="0" bIns="0" rtlCol="0" anchor="ctr"/>
+          <a:lstStyle/>
+          <a:p>
+            <a:pPr marL="0" indent="0" algn="r">
+              <a:buNone/>
+            </a:pPr>
+            <a:r>
+              <a:rPr lang="es-AR" sz="900" dirty="0">
+                <a:solidFill>
+                  <a:srgbClr val="5B6178"/>
+                </a:solidFill>
+                <a:latin typeface="Calibri" pitchFamily="34" charset="0"/>
+                <a:ea typeface="Calibri" pitchFamily="34" charset="-122"/>
+                <a:cs typeface="Calibri" pitchFamily="34" charset="-120"/>
+              </a:rPr>
+              <a:t>2</a:t>
+            </a:r>
           </a:p>
         </p:txBody>
       </p:sp>

</xml_diff>

<commit_message>
FIX presentacion. Arreglo el orden de una diapositiva
</commit_message>
<xml_diff>
--- a/presentacion/GraphQL-vs-REST.pptx
+++ b/presentacion/GraphQL-vs-REST.pptx
@@ -5,19 +5,19 @@
     <p:sldMasterId id="2147483648" r:id="rId1"/>
   </p:sldMasterIdLst>
   <p:notesMasterIdLst>
-    <p:notesMasterId r:id="rId10"/>
+    <p:notesMasterId r:id="rId12"/>
   </p:notesMasterIdLst>
   <p:sldIdLst>
     <p:sldId id="256" r:id="rId2"/>
-    <p:sldId id="264" r:id="rId15"/>
     <p:sldId id="257" r:id="rId3"/>
-    <p:sldId id="258" r:id="rId4"/>
-    <p:sldId id="259" r:id="rId5"/>
-    <p:sldId id="260" r:id="rId6"/>
-    <p:sldId id="261" r:id="rId7"/>
-    <p:sldId id="262" r:id="rId8"/>
-    <p:sldId id="263" r:id="rId9"/>
-    <p:sldId id="265" r:id="rId16"/>
+    <p:sldId id="264" r:id="rId4"/>
+    <p:sldId id="258" r:id="rId5"/>
+    <p:sldId id="259" r:id="rId6"/>
+    <p:sldId id="260" r:id="rId7"/>
+    <p:sldId id="261" r:id="rId8"/>
+    <p:sldId id="262" r:id="rId9"/>
+    <p:sldId id="263" r:id="rId10"/>
+    <p:sldId id="265" r:id="rId11"/>
   </p:sldIdLst>
   <p:sldSz cx="9144000" cy="5143500" type="screen16x9"/>
   <p:notesSz cx="5143500" cy="9144000"/>
@@ -119,6 +119,35 @@
     </p:ext>
   </p:extLst>
 </p:presentation>
+</file>
+
+<file path=ppt/revisionInfo.xml><?xml version="1.0" encoding="utf-8"?>
+<p1510:revInfo xmlns:a="http://schemas.openxmlformats.org/drawingml/2006/main" xmlns:r="http://schemas.openxmlformats.org/officeDocument/2006/relationships" xmlns:p1510="http://schemas.microsoft.com/office/powerpoint/2015/10/main">
+  <p1510:revLst>
+    <p1510:client id="{00000000-0000-0000-0000-000000000000}" v="1" dt="2026-10-16T10:33:21.007"/>
+  </p1510:revLst>
+</p1510:revInfo>
+</file>
+
+<file path=ppt/changesInfos/changesInfo1.xml><?xml version="1.0" encoding="utf-8"?>
+<pc:chgInfo xmlns:a="http://schemas.openxmlformats.org/drawingml/2006/main" xmlns:r="http://schemas.openxmlformats.org/officeDocument/2006/relationships" xmlns:ac="http://schemas.microsoft.com/office/drawing/2013/main/command" xmlns:pc="http://schemas.microsoft.com/office/powerpoint/2013/main/command">
+  <pc:docChgLst>
+    <pc:chgData name="Emiliano Francisco Gamba" userId="S::egamba@frro.utn.edu.ar::8934d685-5d5f-4446-8455-3b04002d74ef" providerId="AD" clId="Web-{00000000-0000-0000-0000-000000000000}"/>
+    <pc:docChg chg="sldOrd">
+      <pc:chgData name="Emiliano Francisco Gamba" userId="S::egamba@frro.utn.edu.ar::8934d685-5d5f-4446-8455-3b04002d74ef" providerId="AD" clId="Web-{00000000-0000-0000-0000-000000000000}" dt="2026-10-16T10:33:21.007" v="0"/>
+      <pc:docMkLst>
+        <pc:docMk/>
+      </pc:docMkLst>
+      <pc:sldChg chg="ord">
+        <pc:chgData name="Emiliano Francisco Gamba" userId="S::egamba@frro.utn.edu.ar::8934d685-5d5f-4446-8455-3b04002d74ef" providerId="AD" clId="Web-{00000000-0000-0000-0000-000000000000}" dt="2026-10-16T10:33:21.007" v="0"/>
+        <pc:sldMkLst>
+          <pc:docMk/>
+          <pc:sldMk cId="0" sldId="264"/>
+        </pc:sldMkLst>
+      </pc:sldChg>
+    </pc:docChg>
+  </pc:docChgLst>
+</pc:chgInfo>
 </file>
 
 <file path=ppt/notesMasters/notesMaster1.xml><?xml version="1.0" encoding="utf-8"?>
@@ -401,7 +430,7 @@
           <a:p>
             <a:fld id="{F7021451-1387-4CA6-816F-3879F97B5CBC}" type="slidenum">
               <a:rPr lang="en-US"/>
-              <a:t>2</a:t>
+              <a:t>3</a:t>
             </a:fld>
             <a:endParaRPr lang="en-US"/>
           </a:p>
@@ -488,7 +517,7 @@
           <a:p>
             <a:fld id="{F7021451-1387-4CA6-816F-3879F97B5CBC}" type="slidenum">
               <a:rPr lang="en-US"/>
-              <a:t>3</a:t>
+              <a:t>4</a:t>
             </a:fld>
             <a:endParaRPr lang="en-US"/>
           </a:p>
@@ -575,7 +604,7 @@
           <a:p>
             <a:fld id="{F7021451-1387-4CA6-816F-3879F97B5CBC}" type="slidenum">
               <a:rPr lang="en-US"/>
-              <a:t>4</a:t>
+              <a:t>5</a:t>
             </a:fld>
             <a:endParaRPr lang="en-US"/>
           </a:p>
@@ -662,7 +691,7 @@
           <a:p>
             <a:fld id="{F7021451-1387-4CA6-816F-3879F97B5CBC}" type="slidenum">
               <a:rPr lang="en-US"/>
-              <a:t>5</a:t>
+              <a:t>6</a:t>
             </a:fld>
             <a:endParaRPr lang="en-US"/>
           </a:p>
@@ -749,7 +778,7 @@
           <a:p>
             <a:fld id="{F7021451-1387-4CA6-816F-3879F97B5CBC}" type="slidenum">
               <a:rPr lang="en-US"/>
-              <a:t>6</a:t>
+              <a:t>7</a:t>
             </a:fld>
             <a:endParaRPr lang="en-US"/>
           </a:p>
@@ -836,7 +865,7 @@
           <a:p>
             <a:fld id="{F7021451-1387-4CA6-816F-3879F97B5CBC}" type="slidenum">
               <a:rPr lang="en-US"/>
-              <a:t>7</a:t>
+              <a:t>8</a:t>
             </a:fld>
             <a:endParaRPr lang="en-US"/>
           </a:p>
@@ -923,7 +952,7 @@
           <a:p>
             <a:fld id="{F7021451-1387-4CA6-816F-3879F97B5CBC}" type="slidenum">
               <a:rPr lang="en-US"/>
-              <a:t>8</a:t>
+              <a:t>9</a:t>
             </a:fld>
             <a:endParaRPr lang="en-US"/>
           </a:p>
@@ -3397,6 +3426,859 @@
 
 <file path=ppt/slides/slide3.xml><?xml version="1.0" encoding="utf-8"?>
 <p:sld xmlns:a="http://schemas.openxmlformats.org/drawingml/2006/main" xmlns:r="http://schemas.openxmlformats.org/officeDocument/2006/relationships" xmlns:p="http://schemas.openxmlformats.org/presentationml/2006/main">
+  <p:cSld name="Slide 2">
+    <p:bg>
+      <p:bgPr>
+        <a:solidFill>
+          <a:srgbClr val="FFFFFF"/>
+        </a:solidFill>
+        <a:effectLst/>
+      </p:bgPr>
+    </p:bg>
+    <p:spTree>
+      <p:nvGrpSpPr>
+        <p:cNvPr id="1" name=""/>
+        <p:cNvGrpSpPr/>
+        <p:nvPr/>
+      </p:nvGrpSpPr>
+      <p:grpSpPr>
+        <a:xfrm>
+          <a:off x="0" y="0"/>
+          <a:ext cx="0" cy="0"/>
+          <a:chOff x="0" y="0"/>
+          <a:chExt cx="0" cy="0"/>
+        </a:xfrm>
+      </p:grpSpPr>
+      <p:sp>
+        <p:nvSpPr>
+          <p:cNvPr id="101" name="Text 101"/>
+          <p:cNvSpPr txBox="1"/>
+          <p:nvPr/>
+        </p:nvSpPr>
+        <p:spPr>
+          <a:xfrm>
+            <a:off x="457200" y="274320"/>
+            <a:ext cx="8229600" cy="685800"/>
+          </a:xfrm>
+          <a:prstGeom prst="rect">
+            <a:avLst/>
+          </a:prstGeom>
+          <a:noFill/>
+          <a:ln/>
+        </p:spPr>
+        <p:txBody>
+          <a:bodyPr wrap="square" lIns="0" tIns="0" rIns="0" bIns="0" rtlCol="0" anchor="ctr"/>
+          <a:lstStyle/>
+          <a:p>
+            <a:pPr marL="0" indent="0">
+              <a:buNone/>
+            </a:pPr>
+            <a:r>
+              <a:rPr lang="es-AR" sz="3200" b="1" dirty="0">
+                <a:solidFill>
+                  <a:srgbClr val="1B1F3B"/>
+                </a:solidFill>
+                <a:latin typeface="Cambria" pitchFamily="34" charset="0"/>
+                <a:ea typeface="Cambria" pitchFamily="34" charset="-122"/>
+                <a:cs typeface="Cambria" pitchFamily="34" charset="-120"/>
+              </a:rPr>
+              <a:t>Un poco de historia</a:t>
+            </a:r>
+          </a:p>
+        </p:txBody>
+      </p:sp>
+      <p:sp>
+        <p:nvSpPr>
+          <p:cNvPr id="102" name="Text 102"/>
+          <p:cNvSpPr txBox="1"/>
+          <p:nvPr/>
+        </p:nvSpPr>
+        <p:spPr>
+          <a:xfrm>
+            <a:off x="457200" y="1051560"/>
+            <a:ext cx="8229600" cy="548640"/>
+          </a:xfrm>
+          <a:prstGeom prst="rect">
+            <a:avLst/>
+          </a:prstGeom>
+          <a:noFill/>
+          <a:ln/>
+        </p:spPr>
+        <p:txBody>
+          <a:bodyPr wrap="square" lIns="0" tIns="0" rIns="0" bIns="0" rtlCol="0" anchor="ctr"/>
+          <a:lstStyle/>
+          <a:p>
+            <a:pPr marL="0" indent="0">
+              <a:buNone/>
+            </a:pPr>
+            <a:r>
+              <a:rPr lang="es-AR" sz="2000" dirty="0">
+                <a:solidFill>
+                  <a:srgbClr val="1B1F3B"/>
+                </a:solidFill>
+                <a:latin typeface="Calibri" pitchFamily="34" charset="0"/>
+                <a:ea typeface="Calibri" pitchFamily="34" charset="-122"/>
+                <a:cs typeface="Calibri" pitchFamily="34" charset="-120"/>
+              </a:rPr>
+              <a:t>Creado por Facebook en 2012 y liberado como código abierto en 2015.</a:t>
+            </a:r>
+          </a:p>
+        </p:txBody>
+      </p:sp>
+      <p:sp>
+        <p:nvSpPr>
+          <p:cNvPr id="103" name="Card 103"/>
+          <p:cNvSpPr/>
+          <p:nvPr/>
+        </p:nvSpPr>
+        <p:spPr>
+          <a:xfrm>
+            <a:off x="457200" y="1783080"/>
+            <a:ext cx="1920240" cy="1828800"/>
+          </a:xfrm>
+          <a:prstGeom prst="roundRect">
+            <a:avLst>
+              <a:gd name="adj" fmla="val 5000"/>
+            </a:avLst>
+          </a:prstGeom>
+          <a:solidFill>
+            <a:srgbClr val="F6EEF6"/>
+          </a:solidFill>
+          <a:ln w="9525">
+            <a:solidFill>
+              <a:srgbClr val="E3D6E3"/>
+            </a:solidFill>
+          </a:ln>
+        </p:spPr>
+        <p:txBody>
+          <a:bodyPr/>
+          <a:lstStyle/>
+          <a:p>
+            <a:endParaRPr lang="es-AR"/>
+          </a:p>
+        </p:txBody>
+      </p:sp>
+      <p:sp>
+        <p:nvSpPr>
+          <p:cNvPr id="104" name="Text 104"/>
+          <p:cNvSpPr txBox="1"/>
+          <p:nvPr/>
+        </p:nvSpPr>
+        <p:spPr>
+          <a:xfrm>
+            <a:off x="640080" y="1920240"/>
+            <a:ext cx="1554480" cy="411480"/>
+          </a:xfrm>
+          <a:prstGeom prst="rect">
+            <a:avLst/>
+          </a:prstGeom>
+          <a:noFill/>
+          <a:ln/>
+        </p:spPr>
+        <p:txBody>
+          <a:bodyPr wrap="square" lIns="0" tIns="0" rIns="0" bIns="0" rtlCol="0" anchor="ctr"/>
+          <a:lstStyle/>
+          <a:p>
+            <a:pPr marL="0" indent="0">
+              <a:buNone/>
+            </a:pPr>
+            <a:r>
+              <a:rPr lang="es-AR" sz="2800" b="1" dirty="0">
+                <a:solidFill>
+                  <a:srgbClr val="E10098"/>
+                </a:solidFill>
+                <a:latin typeface="Cambria" pitchFamily="34" charset="0"/>
+                <a:ea typeface="Cambria" pitchFamily="34" charset="-122"/>
+                <a:cs typeface="Cambria" pitchFamily="34" charset="-120"/>
+              </a:rPr>
+              <a:t>2012</a:t>
+            </a:r>
+          </a:p>
+        </p:txBody>
+      </p:sp>
+      <p:sp>
+        <p:nvSpPr>
+          <p:cNvPr id="105" name="Text 105"/>
+          <p:cNvSpPr txBox="1"/>
+          <p:nvPr/>
+        </p:nvSpPr>
+        <p:spPr>
+          <a:xfrm>
+            <a:off x="640080" y="2377440"/>
+            <a:ext cx="1554480" cy="274320"/>
+          </a:xfrm>
+          <a:prstGeom prst="rect">
+            <a:avLst/>
+          </a:prstGeom>
+          <a:noFill/>
+          <a:ln/>
+        </p:spPr>
+        <p:txBody>
+          <a:bodyPr wrap="square" lIns="0" tIns="0" rIns="0" bIns="0" rtlCol="0" anchor="ctr"/>
+          <a:lstStyle/>
+          <a:p>
+            <a:pPr marL="0" indent="0">
+              <a:buNone/>
+            </a:pPr>
+            <a:r>
+              <a:rPr lang="es-AR" sz="1400" b="1" dirty="0">
+                <a:solidFill>
+                  <a:srgbClr val="1B1F3B"/>
+                </a:solidFill>
+                <a:latin typeface="Cambria" pitchFamily="34" charset="0"/>
+                <a:ea typeface="Cambria" pitchFamily="34" charset="-122"/>
+                <a:cs typeface="Cambria" pitchFamily="34" charset="-120"/>
+              </a:rPr>
+              <a:t>Nace en Facebook</a:t>
+            </a:r>
+          </a:p>
+        </p:txBody>
+      </p:sp>
+      <p:sp>
+        <p:nvSpPr>
+          <p:cNvPr id="106" name="Text 106"/>
+          <p:cNvSpPr txBox="1"/>
+          <p:nvPr/>
+        </p:nvSpPr>
+        <p:spPr>
+          <a:xfrm>
+            <a:off x="640080" y="2743200"/>
+            <a:ext cx="1554480" cy="777240"/>
+          </a:xfrm>
+          <a:prstGeom prst="rect">
+            <a:avLst/>
+          </a:prstGeom>
+          <a:noFill/>
+          <a:ln/>
+        </p:spPr>
+        <p:txBody>
+          <a:bodyPr wrap="square" lIns="0" tIns="0" rIns="0" bIns="0" rtlCol="0" anchor="t"/>
+          <a:lstStyle/>
+          <a:p>
+            <a:pPr marL="0" indent="0">
+              <a:buNone/>
+            </a:pPr>
+            <a:r>
+              <a:rPr lang="es-AR" sz="1200" dirty="0">
+                <a:solidFill>
+                  <a:srgbClr val="5B6178"/>
+                </a:solidFill>
+                <a:latin typeface="Calibri" pitchFamily="34" charset="0"/>
+                <a:ea typeface="Calibri" pitchFamily="34" charset="-122"/>
+                <a:cs typeface="Calibri" pitchFamily="34" charset="-120"/>
+              </a:rPr>
+              <a:t>La app de iOS pasa a ser nativa y el News Feed necesita datos anidados en pocas llamadas.</a:t>
+            </a:r>
+          </a:p>
+        </p:txBody>
+      </p:sp>
+      <p:sp>
+        <p:nvSpPr>
+          <p:cNvPr id="107" name="Card 107"/>
+          <p:cNvSpPr/>
+          <p:nvPr/>
+        </p:nvSpPr>
+        <p:spPr>
+          <a:xfrm>
+            <a:off x="2560320" y="1783080"/>
+            <a:ext cx="1920240" cy="1828800"/>
+          </a:xfrm>
+          <a:prstGeom prst="roundRect">
+            <a:avLst>
+              <a:gd name="adj" fmla="val 5000"/>
+            </a:avLst>
+          </a:prstGeom>
+          <a:solidFill>
+            <a:srgbClr val="F6EEF6"/>
+          </a:solidFill>
+          <a:ln w="9525">
+            <a:solidFill>
+              <a:srgbClr val="E3D6E3"/>
+            </a:solidFill>
+          </a:ln>
+        </p:spPr>
+        <p:txBody>
+          <a:bodyPr/>
+          <a:lstStyle/>
+          <a:p>
+            <a:endParaRPr lang="es-AR"/>
+          </a:p>
+        </p:txBody>
+      </p:sp>
+      <p:sp>
+        <p:nvSpPr>
+          <p:cNvPr id="108" name="Text 108"/>
+          <p:cNvSpPr txBox="1"/>
+          <p:nvPr/>
+        </p:nvSpPr>
+        <p:spPr>
+          <a:xfrm>
+            <a:off x="2743200" y="1920240"/>
+            <a:ext cx="1554480" cy="411480"/>
+          </a:xfrm>
+          <a:prstGeom prst="rect">
+            <a:avLst/>
+          </a:prstGeom>
+          <a:noFill/>
+          <a:ln/>
+        </p:spPr>
+        <p:txBody>
+          <a:bodyPr wrap="square" lIns="0" tIns="0" rIns="0" bIns="0" rtlCol="0" anchor="ctr"/>
+          <a:lstStyle/>
+          <a:p>
+            <a:pPr marL="0" indent="0">
+              <a:buNone/>
+            </a:pPr>
+            <a:r>
+              <a:rPr lang="es-AR" sz="2800" b="1" dirty="0">
+                <a:solidFill>
+                  <a:srgbClr val="E10098"/>
+                </a:solidFill>
+                <a:latin typeface="Cambria" pitchFamily="34" charset="0"/>
+                <a:ea typeface="Cambria" pitchFamily="34" charset="-122"/>
+                <a:cs typeface="Cambria" pitchFamily="34" charset="-120"/>
+              </a:rPr>
+              <a:t>2015</a:t>
+            </a:r>
+          </a:p>
+        </p:txBody>
+      </p:sp>
+      <p:sp>
+        <p:nvSpPr>
+          <p:cNvPr id="109" name="Text 109"/>
+          <p:cNvSpPr txBox="1"/>
+          <p:nvPr/>
+        </p:nvSpPr>
+        <p:spPr>
+          <a:xfrm>
+            <a:off x="2743200" y="2377440"/>
+            <a:ext cx="1554480" cy="274320"/>
+          </a:xfrm>
+          <a:prstGeom prst="rect">
+            <a:avLst/>
+          </a:prstGeom>
+          <a:noFill/>
+          <a:ln/>
+        </p:spPr>
+        <p:txBody>
+          <a:bodyPr wrap="square" lIns="0" tIns="0" rIns="0" bIns="0" rtlCol="0" anchor="ctr"/>
+          <a:lstStyle/>
+          <a:p>
+            <a:pPr marL="0" indent="0">
+              <a:buNone/>
+            </a:pPr>
+            <a:r>
+              <a:rPr lang="es-AR" sz="1400" b="1" dirty="0">
+                <a:solidFill>
+                  <a:srgbClr val="1B1F3B"/>
+                </a:solidFill>
+                <a:latin typeface="Cambria" pitchFamily="34" charset="0"/>
+                <a:ea typeface="Cambria" pitchFamily="34" charset="-122"/>
+                <a:cs typeface="Cambria" pitchFamily="34" charset="-120"/>
+              </a:rPr>
+              <a:t>Código abierto</a:t>
+            </a:r>
+          </a:p>
+        </p:txBody>
+      </p:sp>
+      <p:sp>
+        <p:nvSpPr>
+          <p:cNvPr id="110" name="Text 110"/>
+          <p:cNvSpPr txBox="1"/>
+          <p:nvPr/>
+        </p:nvSpPr>
+        <p:spPr>
+          <a:xfrm>
+            <a:off x="2743200" y="2743200"/>
+            <a:ext cx="1554480" cy="777240"/>
+          </a:xfrm>
+          <a:prstGeom prst="rect">
+            <a:avLst/>
+          </a:prstGeom>
+          <a:noFill/>
+          <a:ln/>
+        </p:spPr>
+        <p:txBody>
+          <a:bodyPr wrap="square" lIns="0" tIns="0" rIns="0" bIns="0" rtlCol="0" anchor="t"/>
+          <a:lstStyle/>
+          <a:p>
+            <a:pPr marL="0" indent="0">
+              <a:buNone/>
+            </a:pPr>
+            <a:r>
+              <a:rPr lang="es-AR" sz="1200" dirty="0">
+                <a:solidFill>
+                  <a:srgbClr val="5B6178"/>
+                </a:solidFill>
+                <a:latin typeface="Calibri" pitchFamily="34" charset="0"/>
+                <a:ea typeface="Calibri" pitchFamily="34" charset="-122"/>
+                <a:cs typeface="Calibri" pitchFamily="34" charset="-120"/>
+              </a:rPr>
+              <a:t>Facebook publica la especificación y la implementación de referencia, graphql-js.</a:t>
+            </a:r>
+          </a:p>
+        </p:txBody>
+      </p:sp>
+      <p:sp>
+        <p:nvSpPr>
+          <p:cNvPr id="111" name="Card 111"/>
+          <p:cNvSpPr/>
+          <p:nvPr/>
+        </p:nvSpPr>
+        <p:spPr>
+          <a:xfrm>
+            <a:off x="4663440" y="1783080"/>
+            <a:ext cx="1920240" cy="1828800"/>
+          </a:xfrm>
+          <a:prstGeom prst="roundRect">
+            <a:avLst>
+              <a:gd name="adj" fmla="val 5000"/>
+            </a:avLst>
+          </a:prstGeom>
+          <a:solidFill>
+            <a:srgbClr val="F6EEF6"/>
+          </a:solidFill>
+          <a:ln w="9525">
+            <a:solidFill>
+              <a:srgbClr val="E3D6E3"/>
+            </a:solidFill>
+          </a:ln>
+        </p:spPr>
+        <p:txBody>
+          <a:bodyPr/>
+          <a:lstStyle/>
+          <a:p>
+            <a:endParaRPr lang="es-AR"/>
+          </a:p>
+        </p:txBody>
+      </p:sp>
+      <p:sp>
+        <p:nvSpPr>
+          <p:cNvPr id="112" name="Text 112"/>
+          <p:cNvSpPr txBox="1"/>
+          <p:nvPr/>
+        </p:nvSpPr>
+        <p:spPr>
+          <a:xfrm>
+            <a:off x="4846320" y="1920240"/>
+            <a:ext cx="1554480" cy="411480"/>
+          </a:xfrm>
+          <a:prstGeom prst="rect">
+            <a:avLst/>
+          </a:prstGeom>
+          <a:noFill/>
+          <a:ln/>
+        </p:spPr>
+        <p:txBody>
+          <a:bodyPr wrap="square" lIns="0" tIns="0" rIns="0" bIns="0" rtlCol="0" anchor="ctr"/>
+          <a:lstStyle/>
+          <a:p>
+            <a:pPr marL="0" indent="0">
+              <a:buNone/>
+            </a:pPr>
+            <a:r>
+              <a:rPr lang="es-AR" sz="2800" b="1" dirty="0">
+                <a:solidFill>
+                  <a:srgbClr val="E10098"/>
+                </a:solidFill>
+                <a:latin typeface="Cambria" pitchFamily="34" charset="0"/>
+                <a:ea typeface="Cambria" pitchFamily="34" charset="-122"/>
+                <a:cs typeface="Cambria" pitchFamily="34" charset="-120"/>
+              </a:rPr>
+              <a:t>2016</a:t>
+            </a:r>
+          </a:p>
+        </p:txBody>
+      </p:sp>
+      <p:sp>
+        <p:nvSpPr>
+          <p:cNvPr id="113" name="Text 113"/>
+          <p:cNvSpPr txBox="1"/>
+          <p:nvPr/>
+        </p:nvSpPr>
+        <p:spPr>
+          <a:xfrm>
+            <a:off x="4846320" y="2377440"/>
+            <a:ext cx="1554480" cy="274320"/>
+          </a:xfrm>
+          <a:prstGeom prst="rect">
+            <a:avLst/>
+          </a:prstGeom>
+          <a:noFill/>
+          <a:ln/>
+        </p:spPr>
+        <p:txBody>
+          <a:bodyPr wrap="square" lIns="0" tIns="0" rIns="0" bIns="0" rtlCol="0" anchor="ctr"/>
+          <a:lstStyle/>
+          <a:p>
+            <a:pPr marL="0" indent="0">
+              <a:buNone/>
+            </a:pPr>
+            <a:r>
+              <a:rPr lang="es-AR" sz="1400" b="1" dirty="0">
+                <a:solidFill>
+                  <a:srgbClr val="1B1F3B"/>
+                </a:solidFill>
+                <a:latin typeface="Cambria" pitchFamily="34" charset="0"/>
+                <a:ea typeface="Cambria" pitchFamily="34" charset="-122"/>
+                <a:cs typeface="Cambria" pitchFamily="34" charset="-120"/>
+              </a:rPr>
+              <a:t>Llega a la industria</a:t>
+            </a:r>
+          </a:p>
+        </p:txBody>
+      </p:sp>
+      <p:sp>
+        <p:nvSpPr>
+          <p:cNvPr id="114" name="Text 114"/>
+          <p:cNvSpPr txBox="1"/>
+          <p:nvPr/>
+        </p:nvSpPr>
+        <p:spPr>
+          <a:xfrm>
+            <a:off x="4846320" y="2743200"/>
+            <a:ext cx="1554480" cy="777240"/>
+          </a:xfrm>
+          <a:prstGeom prst="rect">
+            <a:avLst/>
+          </a:prstGeom>
+          <a:noFill/>
+          <a:ln/>
+        </p:spPr>
+        <p:txBody>
+          <a:bodyPr wrap="square" lIns="0" tIns="0" rIns="0" bIns="0" rtlCol="0" anchor="t"/>
+          <a:lstStyle/>
+          <a:p>
+            <a:pPr marL="0" indent="0">
+              <a:buNone/>
+            </a:pPr>
+            <a:r>
+              <a:rPr lang="es-AR" sz="1200" dirty="0">
+                <a:solidFill>
+                  <a:srgbClr val="5B6178"/>
+                </a:solidFill>
+                <a:latin typeface="Calibri" pitchFamily="34" charset="0"/>
+                <a:ea typeface="Calibri" pitchFamily="34" charset="-122"/>
+                <a:cs typeface="Calibri" pitchFamily="34" charset="-120"/>
+              </a:rPr>
+              <a:t>GitHub lanza su API v4 en GraphQL; le siguen Shopify, Netflix y otros.</a:t>
+            </a:r>
+          </a:p>
+        </p:txBody>
+      </p:sp>
+      <p:sp>
+        <p:nvSpPr>
+          <p:cNvPr id="115" name="Card 115"/>
+          <p:cNvSpPr/>
+          <p:nvPr/>
+        </p:nvSpPr>
+        <p:spPr>
+          <a:xfrm>
+            <a:off x="6766560" y="1783080"/>
+            <a:ext cx="1920240" cy="1828800"/>
+          </a:xfrm>
+          <a:prstGeom prst="roundRect">
+            <a:avLst>
+              <a:gd name="adj" fmla="val 5000"/>
+            </a:avLst>
+          </a:prstGeom>
+          <a:solidFill>
+            <a:srgbClr val="F6EEF6"/>
+          </a:solidFill>
+          <a:ln w="9525">
+            <a:solidFill>
+              <a:srgbClr val="E3D6E3"/>
+            </a:solidFill>
+          </a:ln>
+        </p:spPr>
+        <p:txBody>
+          <a:bodyPr/>
+          <a:lstStyle/>
+          <a:p>
+            <a:endParaRPr lang="es-AR"/>
+          </a:p>
+        </p:txBody>
+      </p:sp>
+      <p:sp>
+        <p:nvSpPr>
+          <p:cNvPr id="116" name="Text 116"/>
+          <p:cNvSpPr txBox="1"/>
+          <p:nvPr/>
+        </p:nvSpPr>
+        <p:spPr>
+          <a:xfrm>
+            <a:off x="6949440" y="1920240"/>
+            <a:ext cx="1554480" cy="411480"/>
+          </a:xfrm>
+          <a:prstGeom prst="rect">
+            <a:avLst/>
+          </a:prstGeom>
+          <a:noFill/>
+          <a:ln/>
+        </p:spPr>
+        <p:txBody>
+          <a:bodyPr wrap="square" lIns="0" tIns="0" rIns="0" bIns="0" rtlCol="0" anchor="ctr"/>
+          <a:lstStyle/>
+          <a:p>
+            <a:pPr marL="0" indent="0">
+              <a:buNone/>
+            </a:pPr>
+            <a:r>
+              <a:rPr lang="es-AR" sz="2800" b="1" dirty="0">
+                <a:solidFill>
+                  <a:srgbClr val="E10098"/>
+                </a:solidFill>
+                <a:latin typeface="Cambria" pitchFamily="34" charset="0"/>
+                <a:ea typeface="Cambria" pitchFamily="34" charset="-122"/>
+                <a:cs typeface="Cambria" pitchFamily="34" charset="-120"/>
+              </a:rPr>
+              <a:t>2018</a:t>
+            </a:r>
+          </a:p>
+        </p:txBody>
+      </p:sp>
+      <p:sp>
+        <p:nvSpPr>
+          <p:cNvPr id="117" name="Text 117"/>
+          <p:cNvSpPr txBox="1"/>
+          <p:nvPr/>
+        </p:nvSpPr>
+        <p:spPr>
+          <a:xfrm>
+            <a:off x="6949440" y="2377440"/>
+            <a:ext cx="1554480" cy="274320"/>
+          </a:xfrm>
+          <a:prstGeom prst="rect">
+            <a:avLst/>
+          </a:prstGeom>
+          <a:noFill/>
+          <a:ln/>
+        </p:spPr>
+        <p:txBody>
+          <a:bodyPr wrap="square" lIns="0" tIns="0" rIns="0" bIns="0" rtlCol="0" anchor="ctr"/>
+          <a:lstStyle/>
+          <a:p>
+            <a:pPr marL="0" indent="0">
+              <a:buNone/>
+            </a:pPr>
+            <a:r>
+              <a:rPr lang="es-AR" sz="1400" b="1" dirty="0">
+                <a:solidFill>
+                  <a:srgbClr val="1B1F3B"/>
+                </a:solidFill>
+                <a:latin typeface="Cambria" pitchFamily="34" charset="0"/>
+                <a:ea typeface="Cambria" pitchFamily="34" charset="-122"/>
+                <a:cs typeface="Cambria" pitchFamily="34" charset="-120"/>
+              </a:rPr>
+              <a:t>Fundación propia</a:t>
+            </a:r>
+          </a:p>
+        </p:txBody>
+      </p:sp>
+      <p:sp>
+        <p:nvSpPr>
+          <p:cNvPr id="118" name="Text 118"/>
+          <p:cNvSpPr txBox="1"/>
+          <p:nvPr/>
+        </p:nvSpPr>
+        <p:spPr>
+          <a:xfrm>
+            <a:off x="6949440" y="2743200"/>
+            <a:ext cx="1554480" cy="777240"/>
+          </a:xfrm>
+          <a:prstGeom prst="rect">
+            <a:avLst/>
+          </a:prstGeom>
+          <a:noFill/>
+          <a:ln/>
+        </p:spPr>
+        <p:txBody>
+          <a:bodyPr wrap="square" lIns="0" tIns="0" rIns="0" bIns="0" rtlCol="0" anchor="t"/>
+          <a:lstStyle/>
+          <a:p>
+            <a:pPr marL="0" indent="0">
+              <a:buNone/>
+            </a:pPr>
+            <a:r>
+              <a:rPr lang="es-AR" sz="1200" dirty="0">
+                <a:solidFill>
+                  <a:srgbClr val="5B6178"/>
+                </a:solidFill>
+                <a:latin typeface="Calibri" pitchFamily="34" charset="0"/>
+                <a:ea typeface="Calibri" pitchFamily="34" charset="-122"/>
+                <a:cs typeface="Calibri" pitchFamily="34" charset="-120"/>
+              </a:rPr>
+              <a:t>Pasa a la GraphQL Foundation, dentro de la Linux Foundation.</a:t>
+            </a:r>
+          </a:p>
+        </p:txBody>
+      </p:sp>
+      <p:sp>
+        <p:nvSpPr>
+          <p:cNvPr id="119" name="Banner 119"/>
+          <p:cNvSpPr/>
+          <p:nvPr/>
+        </p:nvSpPr>
+        <p:spPr>
+          <a:xfrm>
+            <a:off x="457200" y="3749040"/>
+            <a:ext cx="8229600" cy="822960"/>
+          </a:xfrm>
+          <a:prstGeom prst="roundRect">
+            <a:avLst>
+              <a:gd name="adj" fmla="val 12500"/>
+            </a:avLst>
+          </a:prstGeom>
+          <a:solidFill>
+            <a:srgbClr val="E10098"/>
+          </a:solidFill>
+          <a:ln>
+            <a:noFill/>
+          </a:ln>
+        </p:spPr>
+        <p:txBody>
+          <a:bodyPr/>
+          <a:lstStyle/>
+          <a:p>
+            <a:endParaRPr lang="es-AR"/>
+          </a:p>
+        </p:txBody>
+      </p:sp>
+      <p:sp>
+        <p:nvSpPr>
+          <p:cNvPr id="120" name="Text 120"/>
+          <p:cNvSpPr txBox="1"/>
+          <p:nvPr/>
+        </p:nvSpPr>
+        <p:spPr>
+          <a:xfrm>
+            <a:off x="640080" y="3817620"/>
+            <a:ext cx="7863840" cy="685800"/>
+          </a:xfrm>
+          <a:prstGeom prst="rect">
+            <a:avLst/>
+          </a:prstGeom>
+          <a:noFill/>
+          <a:ln/>
+        </p:spPr>
+        <p:txBody>
+          <a:bodyPr wrap="square" lIns="0" tIns="0" rIns="0" bIns="0" rtlCol="0" anchor="ctr"/>
+          <a:lstStyle/>
+          <a:p>
+            <a:pPr marL="0" indent="0">
+              <a:buNone/>
+            </a:pPr>
+            <a:r>
+              <a:rPr lang="es-AR" sz="1400" b="1" dirty="0">
+                <a:solidFill>
+                  <a:srgbClr val="FFFFFF"/>
+                </a:solidFill>
+                <a:latin typeface="Cambria" pitchFamily="34" charset="0"/>
+                <a:ea typeface="Cambria" pitchFamily="34" charset="-122"/>
+                <a:cs typeface="Cambria" pitchFamily="34" charset="-120"/>
+              </a:rPr>
+              <a:t>¿Por qué se creó? </a:t>
+            </a:r>
+            <a:r>
+              <a:rPr lang="es-AR" sz="1400" dirty="0">
+                <a:solidFill>
+                  <a:srgbClr val="FFFFFF"/>
+                </a:solidFill>
+                <a:latin typeface="Calibri" pitchFamily="34" charset="0"/>
+                <a:ea typeface="Calibri" pitchFamily="34" charset="-122"/>
+                <a:cs typeface="Calibri" pitchFamily="34" charset="-120"/>
+              </a:rPr>
+              <a:t>Con REST, cada pantalla del celular hacía varias llamadas y recibía datos de más, sobre redes móviles lentas. GraphQL deja que la pantalla pida justo lo que necesita, en una sola llamada.</a:t>
+            </a:r>
+          </a:p>
+        </p:txBody>
+      </p:sp>
+      <p:sp>
+        <p:nvSpPr>
+          <p:cNvPr id="121" name="Text 121"/>
+          <p:cNvSpPr txBox="1"/>
+          <p:nvPr/>
+        </p:nvSpPr>
+        <p:spPr>
+          <a:xfrm>
+            <a:off x="457200" y="4754880"/>
+            <a:ext cx="5486400" cy="228600"/>
+          </a:xfrm>
+          <a:prstGeom prst="rect">
+            <a:avLst/>
+          </a:prstGeom>
+          <a:noFill/>
+          <a:ln/>
+        </p:spPr>
+        <p:txBody>
+          <a:bodyPr wrap="square" lIns="0" tIns="0" rIns="0" bIns="0" rtlCol="0" anchor="ctr"/>
+          <a:lstStyle/>
+          <a:p>
+            <a:pPr marL="0" indent="0">
+              <a:buNone/>
+            </a:pPr>
+            <a:r>
+              <a:rPr lang="es-AR" sz="900" dirty="0">
+                <a:solidFill>
+                  <a:srgbClr val="5B6178"/>
+                </a:solidFill>
+                <a:latin typeface="Calibri" pitchFamily="34" charset="0"/>
+                <a:ea typeface="Calibri" pitchFamily="34" charset="-122"/>
+                <a:cs typeface="Calibri" pitchFamily="34" charset="-120"/>
+              </a:rPr>
+              <a:t>GraphQL y REST · Gamba y Milanesi · 2026</a:t>
+            </a:r>
+          </a:p>
+        </p:txBody>
+      </p:sp>
+      <p:sp>
+        <p:nvSpPr>
+          <p:cNvPr id="122" name="Text 122"/>
+          <p:cNvSpPr txBox="1"/>
+          <p:nvPr/>
+        </p:nvSpPr>
+        <p:spPr>
+          <a:xfrm>
+            <a:off x="8229600" y="4754880"/>
+            <a:ext cx="457200" cy="228600"/>
+          </a:xfrm>
+          <a:prstGeom prst="rect">
+            <a:avLst/>
+          </a:prstGeom>
+          <a:noFill/>
+          <a:ln/>
+        </p:spPr>
+        <p:txBody>
+          <a:bodyPr wrap="square" lIns="0" tIns="0" rIns="0" bIns="0" rtlCol="0" anchor="ctr"/>
+          <a:lstStyle/>
+          <a:p>
+            <a:pPr marL="0" indent="0" algn="r">
+              <a:buNone/>
+            </a:pPr>
+            <a:r>
+              <a:rPr lang="es-AR" sz="900" dirty="0">
+                <a:solidFill>
+                  <a:srgbClr val="5B6178"/>
+                </a:solidFill>
+                <a:latin typeface="Calibri" pitchFamily="34" charset="0"/>
+                <a:ea typeface="Calibri" pitchFamily="34" charset="-122"/>
+                <a:cs typeface="Calibri" pitchFamily="34" charset="-120"/>
+              </a:rPr>
+              <a:t>2</a:t>
+            </a:r>
+          </a:p>
+        </p:txBody>
+      </p:sp>
+    </p:spTree>
+  </p:cSld>
+  <p:clrMapOvr>
+    <a:masterClrMapping/>
+  </p:clrMapOvr>
+</p:sld>
+</file>
+
+<file path=ppt/slides/slide4.xml><?xml version="1.0" encoding="utf-8"?>
+<p:sld xmlns:a="http://schemas.openxmlformats.org/drawingml/2006/main" xmlns:r="http://schemas.openxmlformats.org/officeDocument/2006/relationships" xmlns:p="http://schemas.openxmlformats.org/presentationml/2006/main">
   <p:cSld name="Slide 3">
     <p:bg>
       <p:bgPr>
@@ -4198,7 +5080,7 @@
 </p:sld>
 </file>
 
-<file path=ppt/slides/slide4.xml><?xml version="1.0" encoding="utf-8"?>
+<file path=ppt/slides/slide5.xml><?xml version="1.0" encoding="utf-8"?>
 <p:sld xmlns:a="http://schemas.openxmlformats.org/drawingml/2006/main" xmlns:r="http://schemas.openxmlformats.org/officeDocument/2006/relationships" xmlns:p="http://schemas.openxmlformats.org/presentationml/2006/main">
   <p:cSld name="Slide 4">
     <p:bg>
@@ -5356,7 +6238,7 @@
 </p:sld>
 </file>
 
-<file path=ppt/slides/slide5.xml><?xml version="1.0" encoding="utf-8"?>
+<file path=ppt/slides/slide6.xml><?xml version="1.0" encoding="utf-8"?>
 <p:sld xmlns:a="http://schemas.openxmlformats.org/drawingml/2006/main" xmlns:r="http://schemas.openxmlformats.org/officeDocument/2006/relationships" xmlns:p="http://schemas.openxmlformats.org/presentationml/2006/main">
   <p:cSld name="Slide 5">
     <p:bg>
@@ -6373,7 +7255,7 @@
 </p:sld>
 </file>
 
-<file path=ppt/slides/slide6.xml><?xml version="1.0" encoding="utf-8"?>
+<file path=ppt/slides/slide7.xml><?xml version="1.0" encoding="utf-8"?>
 <p:sld xmlns:a="http://schemas.openxmlformats.org/drawingml/2006/main" xmlns:r="http://schemas.openxmlformats.org/officeDocument/2006/relationships" xmlns:p="http://schemas.openxmlformats.org/presentationml/2006/main">
   <p:cSld name="Slide 6">
     <p:bg>
@@ -7010,7 +7892,7 @@
 </p:sld>
 </file>
 
-<file path=ppt/slides/slide7.xml><?xml version="1.0" encoding="utf-8"?>
+<file path=ppt/slides/slide8.xml><?xml version="1.0" encoding="utf-8"?>
 <p:sld xmlns:a="http://schemas.openxmlformats.org/drawingml/2006/main" xmlns:r="http://schemas.openxmlformats.org/officeDocument/2006/relationships" xmlns:p="http://schemas.openxmlformats.org/presentationml/2006/main">
   <p:cSld name="Slide 7">
     <p:bg>
@@ -8419,7 +9301,7 @@
 </p:sld>
 </file>
 
-<file path=ppt/slides/slide8.xml><?xml version="1.0" encoding="utf-8"?>
+<file path=ppt/slides/slide9.xml><?xml version="1.0" encoding="utf-8"?>
 <p:sld xmlns:a="http://schemas.openxmlformats.org/drawingml/2006/main" xmlns:r="http://schemas.openxmlformats.org/officeDocument/2006/relationships" xmlns:p="http://schemas.openxmlformats.org/presentationml/2006/main">
   <p:cSld name="Slide 8">
     <p:bg>
@@ -9179,859 +10061,6 @@
               <a:t>GraphQL no reemplaza a REST: resuelve un problema puntual.</a:t>
             </a:r>
             <a:endParaRPr lang="en-US" sz="1800" dirty="0"/>
-          </a:p>
-        </p:txBody>
-      </p:sp>
-    </p:spTree>
-  </p:cSld>
-  <p:clrMapOvr>
-    <a:masterClrMapping/>
-  </p:clrMapOvr>
-</p:sld>
-</file>
-
-<file path=ppt/slides/slide9.xml><?xml version="1.0" encoding="utf-8"?>
-<p:sld xmlns:a="http://schemas.openxmlformats.org/drawingml/2006/main" xmlns:r="http://schemas.openxmlformats.org/officeDocument/2006/relationships" xmlns:p="http://schemas.openxmlformats.org/presentationml/2006/main">
-  <p:cSld name="Slide 2">
-    <p:bg>
-      <p:bgPr>
-        <a:solidFill>
-          <a:srgbClr val="FFFFFF"/>
-        </a:solidFill>
-        <a:effectLst/>
-      </p:bgPr>
-    </p:bg>
-    <p:spTree>
-      <p:nvGrpSpPr>
-        <p:cNvPr id="1" name=""/>
-        <p:cNvGrpSpPr/>
-        <p:nvPr/>
-      </p:nvGrpSpPr>
-      <p:grpSpPr>
-        <a:xfrm>
-          <a:off x="0" y="0"/>
-          <a:ext cx="0" cy="0"/>
-          <a:chOff x="0" y="0"/>
-          <a:chExt cx="0" cy="0"/>
-        </a:xfrm>
-      </p:grpSpPr>
-      <p:sp>
-        <p:nvSpPr>
-          <p:cNvPr id="101" name="Text 101"/>
-          <p:cNvSpPr txBox="1"/>
-          <p:nvPr/>
-        </p:nvSpPr>
-        <p:spPr>
-          <a:xfrm>
-            <a:off x="457200" y="274320"/>
-            <a:ext cx="8229600" cy="685800"/>
-          </a:xfrm>
-          <a:prstGeom prst="rect">
-            <a:avLst/>
-          </a:prstGeom>
-          <a:noFill/>
-          <a:ln/>
-        </p:spPr>
-        <p:txBody>
-          <a:bodyPr wrap="square" lIns="0" tIns="0" rIns="0" bIns="0" rtlCol="0" anchor="ctr"/>
-          <a:lstStyle/>
-          <a:p>
-            <a:pPr marL="0" indent="0">
-              <a:buNone/>
-            </a:pPr>
-            <a:r>
-              <a:rPr lang="es-AR" sz="3200" b="1" dirty="0">
-                <a:solidFill>
-                  <a:srgbClr val="1B1F3B"/>
-                </a:solidFill>
-                <a:latin typeface="Cambria" pitchFamily="34" charset="0"/>
-                <a:ea typeface="Cambria" pitchFamily="34" charset="-122"/>
-                <a:cs typeface="Cambria" pitchFamily="34" charset="-120"/>
-              </a:rPr>
-              <a:t>Un poco de historia</a:t>
-            </a:r>
-          </a:p>
-        </p:txBody>
-      </p:sp>
-      <p:sp>
-        <p:nvSpPr>
-          <p:cNvPr id="102" name="Text 102"/>
-          <p:cNvSpPr txBox="1"/>
-          <p:nvPr/>
-        </p:nvSpPr>
-        <p:spPr>
-          <a:xfrm>
-            <a:off x="457200" y="1051560"/>
-            <a:ext cx="8229600" cy="548640"/>
-          </a:xfrm>
-          <a:prstGeom prst="rect">
-            <a:avLst/>
-          </a:prstGeom>
-          <a:noFill/>
-          <a:ln/>
-        </p:spPr>
-        <p:txBody>
-          <a:bodyPr wrap="square" lIns="0" tIns="0" rIns="0" bIns="0" rtlCol="0" anchor="ctr"/>
-          <a:lstStyle/>
-          <a:p>
-            <a:pPr marL="0" indent="0">
-              <a:buNone/>
-            </a:pPr>
-            <a:r>
-              <a:rPr lang="es-AR" sz="2000" dirty="0">
-                <a:solidFill>
-                  <a:srgbClr val="1B1F3B"/>
-                </a:solidFill>
-                <a:latin typeface="Calibri" pitchFamily="34" charset="0"/>
-                <a:ea typeface="Calibri" pitchFamily="34" charset="-122"/>
-                <a:cs typeface="Calibri" pitchFamily="34" charset="-120"/>
-              </a:rPr>
-              <a:t>Creado por Facebook en 2012 y liberado como código abierto en 2015.</a:t>
-            </a:r>
-          </a:p>
-        </p:txBody>
-      </p:sp>
-      <p:sp>
-        <p:nvSpPr>
-          <p:cNvPr id="103" name="Card 103"/>
-          <p:cNvSpPr/>
-          <p:nvPr/>
-        </p:nvSpPr>
-        <p:spPr>
-          <a:xfrm>
-            <a:off x="457200" y="1783080"/>
-            <a:ext cx="1920240" cy="1828800"/>
-          </a:xfrm>
-          <a:prstGeom prst="roundRect">
-            <a:avLst>
-              <a:gd name="adj" fmla="val 5000"/>
-            </a:avLst>
-          </a:prstGeom>
-          <a:solidFill>
-            <a:srgbClr val="F6EEF6"/>
-          </a:solidFill>
-          <a:ln w="9525">
-            <a:solidFill>
-              <a:srgbClr val="E3D6E3"/>
-            </a:solidFill>
-          </a:ln>
-        </p:spPr>
-        <p:txBody>
-          <a:bodyPr/>
-          <a:lstStyle/>
-          <a:p>
-            <a:endParaRPr lang="es-AR"/>
-          </a:p>
-        </p:txBody>
-      </p:sp>
-      <p:sp>
-        <p:nvSpPr>
-          <p:cNvPr id="104" name="Text 104"/>
-          <p:cNvSpPr txBox="1"/>
-          <p:nvPr/>
-        </p:nvSpPr>
-        <p:spPr>
-          <a:xfrm>
-            <a:off x="640080" y="1920240"/>
-            <a:ext cx="1554480" cy="411480"/>
-          </a:xfrm>
-          <a:prstGeom prst="rect">
-            <a:avLst/>
-          </a:prstGeom>
-          <a:noFill/>
-          <a:ln/>
-        </p:spPr>
-        <p:txBody>
-          <a:bodyPr wrap="square" lIns="0" tIns="0" rIns="0" bIns="0" rtlCol="0" anchor="ctr"/>
-          <a:lstStyle/>
-          <a:p>
-            <a:pPr marL="0" indent="0">
-              <a:buNone/>
-            </a:pPr>
-            <a:r>
-              <a:rPr lang="es-AR" sz="2800" b="1" dirty="0">
-                <a:solidFill>
-                  <a:srgbClr val="E10098"/>
-                </a:solidFill>
-                <a:latin typeface="Cambria" pitchFamily="34" charset="0"/>
-                <a:ea typeface="Cambria" pitchFamily="34" charset="-122"/>
-                <a:cs typeface="Cambria" pitchFamily="34" charset="-120"/>
-              </a:rPr>
-              <a:t>2012</a:t>
-            </a:r>
-          </a:p>
-        </p:txBody>
-      </p:sp>
-      <p:sp>
-        <p:nvSpPr>
-          <p:cNvPr id="105" name="Text 105"/>
-          <p:cNvSpPr txBox="1"/>
-          <p:nvPr/>
-        </p:nvSpPr>
-        <p:spPr>
-          <a:xfrm>
-            <a:off x="640080" y="2377440"/>
-            <a:ext cx="1554480" cy="274320"/>
-          </a:xfrm>
-          <a:prstGeom prst="rect">
-            <a:avLst/>
-          </a:prstGeom>
-          <a:noFill/>
-          <a:ln/>
-        </p:spPr>
-        <p:txBody>
-          <a:bodyPr wrap="square" lIns="0" tIns="0" rIns="0" bIns="0" rtlCol="0" anchor="ctr"/>
-          <a:lstStyle/>
-          <a:p>
-            <a:pPr marL="0" indent="0">
-              <a:buNone/>
-            </a:pPr>
-            <a:r>
-              <a:rPr lang="es-AR" sz="1400" b="1" dirty="0">
-                <a:solidFill>
-                  <a:srgbClr val="1B1F3B"/>
-                </a:solidFill>
-                <a:latin typeface="Cambria" pitchFamily="34" charset="0"/>
-                <a:ea typeface="Cambria" pitchFamily="34" charset="-122"/>
-                <a:cs typeface="Cambria" pitchFamily="34" charset="-120"/>
-              </a:rPr>
-              <a:t>Nace en Facebook</a:t>
-            </a:r>
-          </a:p>
-        </p:txBody>
-      </p:sp>
-      <p:sp>
-        <p:nvSpPr>
-          <p:cNvPr id="106" name="Text 106"/>
-          <p:cNvSpPr txBox="1"/>
-          <p:nvPr/>
-        </p:nvSpPr>
-        <p:spPr>
-          <a:xfrm>
-            <a:off x="640080" y="2743200"/>
-            <a:ext cx="1554480" cy="777240"/>
-          </a:xfrm>
-          <a:prstGeom prst="rect">
-            <a:avLst/>
-          </a:prstGeom>
-          <a:noFill/>
-          <a:ln/>
-        </p:spPr>
-        <p:txBody>
-          <a:bodyPr wrap="square" lIns="0" tIns="0" rIns="0" bIns="0" rtlCol="0" anchor="t"/>
-          <a:lstStyle/>
-          <a:p>
-            <a:pPr marL="0" indent="0">
-              <a:buNone/>
-            </a:pPr>
-            <a:r>
-              <a:rPr lang="es-AR" sz="1200" dirty="0">
-                <a:solidFill>
-                  <a:srgbClr val="5B6178"/>
-                </a:solidFill>
-                <a:latin typeface="Calibri" pitchFamily="34" charset="0"/>
-                <a:ea typeface="Calibri" pitchFamily="34" charset="-122"/>
-                <a:cs typeface="Calibri" pitchFamily="34" charset="-120"/>
-              </a:rPr>
-              <a:t>La app de iOS pasa a ser nativa y el News Feed necesita datos anidados en pocas llamadas.</a:t>
-            </a:r>
-          </a:p>
-        </p:txBody>
-      </p:sp>
-      <p:sp>
-        <p:nvSpPr>
-          <p:cNvPr id="107" name="Card 107"/>
-          <p:cNvSpPr/>
-          <p:nvPr/>
-        </p:nvSpPr>
-        <p:spPr>
-          <a:xfrm>
-            <a:off x="2560320" y="1783080"/>
-            <a:ext cx="1920240" cy="1828800"/>
-          </a:xfrm>
-          <a:prstGeom prst="roundRect">
-            <a:avLst>
-              <a:gd name="adj" fmla="val 5000"/>
-            </a:avLst>
-          </a:prstGeom>
-          <a:solidFill>
-            <a:srgbClr val="F6EEF6"/>
-          </a:solidFill>
-          <a:ln w="9525">
-            <a:solidFill>
-              <a:srgbClr val="E3D6E3"/>
-            </a:solidFill>
-          </a:ln>
-        </p:spPr>
-        <p:txBody>
-          <a:bodyPr/>
-          <a:lstStyle/>
-          <a:p>
-            <a:endParaRPr lang="es-AR"/>
-          </a:p>
-        </p:txBody>
-      </p:sp>
-      <p:sp>
-        <p:nvSpPr>
-          <p:cNvPr id="108" name="Text 108"/>
-          <p:cNvSpPr txBox="1"/>
-          <p:nvPr/>
-        </p:nvSpPr>
-        <p:spPr>
-          <a:xfrm>
-            <a:off x="2743200" y="1920240"/>
-            <a:ext cx="1554480" cy="411480"/>
-          </a:xfrm>
-          <a:prstGeom prst="rect">
-            <a:avLst/>
-          </a:prstGeom>
-          <a:noFill/>
-          <a:ln/>
-        </p:spPr>
-        <p:txBody>
-          <a:bodyPr wrap="square" lIns="0" tIns="0" rIns="0" bIns="0" rtlCol="0" anchor="ctr"/>
-          <a:lstStyle/>
-          <a:p>
-            <a:pPr marL="0" indent="0">
-              <a:buNone/>
-            </a:pPr>
-            <a:r>
-              <a:rPr lang="es-AR" sz="2800" b="1" dirty="0">
-                <a:solidFill>
-                  <a:srgbClr val="E10098"/>
-                </a:solidFill>
-                <a:latin typeface="Cambria" pitchFamily="34" charset="0"/>
-                <a:ea typeface="Cambria" pitchFamily="34" charset="-122"/>
-                <a:cs typeface="Cambria" pitchFamily="34" charset="-120"/>
-              </a:rPr>
-              <a:t>2015</a:t>
-            </a:r>
-          </a:p>
-        </p:txBody>
-      </p:sp>
-      <p:sp>
-        <p:nvSpPr>
-          <p:cNvPr id="109" name="Text 109"/>
-          <p:cNvSpPr txBox="1"/>
-          <p:nvPr/>
-        </p:nvSpPr>
-        <p:spPr>
-          <a:xfrm>
-            <a:off x="2743200" y="2377440"/>
-            <a:ext cx="1554480" cy="274320"/>
-          </a:xfrm>
-          <a:prstGeom prst="rect">
-            <a:avLst/>
-          </a:prstGeom>
-          <a:noFill/>
-          <a:ln/>
-        </p:spPr>
-        <p:txBody>
-          <a:bodyPr wrap="square" lIns="0" tIns="0" rIns="0" bIns="0" rtlCol="0" anchor="ctr"/>
-          <a:lstStyle/>
-          <a:p>
-            <a:pPr marL="0" indent="0">
-              <a:buNone/>
-            </a:pPr>
-            <a:r>
-              <a:rPr lang="es-AR" sz="1400" b="1" dirty="0">
-                <a:solidFill>
-                  <a:srgbClr val="1B1F3B"/>
-                </a:solidFill>
-                <a:latin typeface="Cambria" pitchFamily="34" charset="0"/>
-                <a:ea typeface="Cambria" pitchFamily="34" charset="-122"/>
-                <a:cs typeface="Cambria" pitchFamily="34" charset="-120"/>
-              </a:rPr>
-              <a:t>Código abierto</a:t>
-            </a:r>
-          </a:p>
-        </p:txBody>
-      </p:sp>
-      <p:sp>
-        <p:nvSpPr>
-          <p:cNvPr id="110" name="Text 110"/>
-          <p:cNvSpPr txBox="1"/>
-          <p:nvPr/>
-        </p:nvSpPr>
-        <p:spPr>
-          <a:xfrm>
-            <a:off x="2743200" y="2743200"/>
-            <a:ext cx="1554480" cy="777240"/>
-          </a:xfrm>
-          <a:prstGeom prst="rect">
-            <a:avLst/>
-          </a:prstGeom>
-          <a:noFill/>
-          <a:ln/>
-        </p:spPr>
-        <p:txBody>
-          <a:bodyPr wrap="square" lIns="0" tIns="0" rIns="0" bIns="0" rtlCol="0" anchor="t"/>
-          <a:lstStyle/>
-          <a:p>
-            <a:pPr marL="0" indent="0">
-              <a:buNone/>
-            </a:pPr>
-            <a:r>
-              <a:rPr lang="es-AR" sz="1200" dirty="0">
-                <a:solidFill>
-                  <a:srgbClr val="5B6178"/>
-                </a:solidFill>
-                <a:latin typeface="Calibri" pitchFamily="34" charset="0"/>
-                <a:ea typeface="Calibri" pitchFamily="34" charset="-122"/>
-                <a:cs typeface="Calibri" pitchFamily="34" charset="-120"/>
-              </a:rPr>
-              <a:t>Facebook publica la especificación y la implementación de referencia, graphql-js.</a:t>
-            </a:r>
-          </a:p>
-        </p:txBody>
-      </p:sp>
-      <p:sp>
-        <p:nvSpPr>
-          <p:cNvPr id="111" name="Card 111"/>
-          <p:cNvSpPr/>
-          <p:nvPr/>
-        </p:nvSpPr>
-        <p:spPr>
-          <a:xfrm>
-            <a:off x="4663440" y="1783080"/>
-            <a:ext cx="1920240" cy="1828800"/>
-          </a:xfrm>
-          <a:prstGeom prst="roundRect">
-            <a:avLst>
-              <a:gd name="adj" fmla="val 5000"/>
-            </a:avLst>
-          </a:prstGeom>
-          <a:solidFill>
-            <a:srgbClr val="F6EEF6"/>
-          </a:solidFill>
-          <a:ln w="9525">
-            <a:solidFill>
-              <a:srgbClr val="E3D6E3"/>
-            </a:solidFill>
-          </a:ln>
-        </p:spPr>
-        <p:txBody>
-          <a:bodyPr/>
-          <a:lstStyle/>
-          <a:p>
-            <a:endParaRPr lang="es-AR"/>
-          </a:p>
-        </p:txBody>
-      </p:sp>
-      <p:sp>
-        <p:nvSpPr>
-          <p:cNvPr id="112" name="Text 112"/>
-          <p:cNvSpPr txBox="1"/>
-          <p:nvPr/>
-        </p:nvSpPr>
-        <p:spPr>
-          <a:xfrm>
-            <a:off x="4846320" y="1920240"/>
-            <a:ext cx="1554480" cy="411480"/>
-          </a:xfrm>
-          <a:prstGeom prst="rect">
-            <a:avLst/>
-          </a:prstGeom>
-          <a:noFill/>
-          <a:ln/>
-        </p:spPr>
-        <p:txBody>
-          <a:bodyPr wrap="square" lIns="0" tIns="0" rIns="0" bIns="0" rtlCol="0" anchor="ctr"/>
-          <a:lstStyle/>
-          <a:p>
-            <a:pPr marL="0" indent="0">
-              <a:buNone/>
-            </a:pPr>
-            <a:r>
-              <a:rPr lang="es-AR" sz="2800" b="1" dirty="0">
-                <a:solidFill>
-                  <a:srgbClr val="E10098"/>
-                </a:solidFill>
-                <a:latin typeface="Cambria" pitchFamily="34" charset="0"/>
-                <a:ea typeface="Cambria" pitchFamily="34" charset="-122"/>
-                <a:cs typeface="Cambria" pitchFamily="34" charset="-120"/>
-              </a:rPr>
-              <a:t>2016</a:t>
-            </a:r>
-          </a:p>
-        </p:txBody>
-      </p:sp>
-      <p:sp>
-        <p:nvSpPr>
-          <p:cNvPr id="113" name="Text 113"/>
-          <p:cNvSpPr txBox="1"/>
-          <p:nvPr/>
-        </p:nvSpPr>
-        <p:spPr>
-          <a:xfrm>
-            <a:off x="4846320" y="2377440"/>
-            <a:ext cx="1554480" cy="274320"/>
-          </a:xfrm>
-          <a:prstGeom prst="rect">
-            <a:avLst/>
-          </a:prstGeom>
-          <a:noFill/>
-          <a:ln/>
-        </p:spPr>
-        <p:txBody>
-          <a:bodyPr wrap="square" lIns="0" tIns="0" rIns="0" bIns="0" rtlCol="0" anchor="ctr"/>
-          <a:lstStyle/>
-          <a:p>
-            <a:pPr marL="0" indent="0">
-              <a:buNone/>
-            </a:pPr>
-            <a:r>
-              <a:rPr lang="es-AR" sz="1400" b="1" dirty="0">
-                <a:solidFill>
-                  <a:srgbClr val="1B1F3B"/>
-                </a:solidFill>
-                <a:latin typeface="Cambria" pitchFamily="34" charset="0"/>
-                <a:ea typeface="Cambria" pitchFamily="34" charset="-122"/>
-                <a:cs typeface="Cambria" pitchFamily="34" charset="-120"/>
-              </a:rPr>
-              <a:t>Llega a la industria</a:t>
-            </a:r>
-          </a:p>
-        </p:txBody>
-      </p:sp>
-      <p:sp>
-        <p:nvSpPr>
-          <p:cNvPr id="114" name="Text 114"/>
-          <p:cNvSpPr txBox="1"/>
-          <p:nvPr/>
-        </p:nvSpPr>
-        <p:spPr>
-          <a:xfrm>
-            <a:off x="4846320" y="2743200"/>
-            <a:ext cx="1554480" cy="777240"/>
-          </a:xfrm>
-          <a:prstGeom prst="rect">
-            <a:avLst/>
-          </a:prstGeom>
-          <a:noFill/>
-          <a:ln/>
-        </p:spPr>
-        <p:txBody>
-          <a:bodyPr wrap="square" lIns="0" tIns="0" rIns="0" bIns="0" rtlCol="0" anchor="t"/>
-          <a:lstStyle/>
-          <a:p>
-            <a:pPr marL="0" indent="0">
-              <a:buNone/>
-            </a:pPr>
-            <a:r>
-              <a:rPr lang="es-AR" sz="1200" dirty="0">
-                <a:solidFill>
-                  <a:srgbClr val="5B6178"/>
-                </a:solidFill>
-                <a:latin typeface="Calibri" pitchFamily="34" charset="0"/>
-                <a:ea typeface="Calibri" pitchFamily="34" charset="-122"/>
-                <a:cs typeface="Calibri" pitchFamily="34" charset="-120"/>
-              </a:rPr>
-              <a:t>GitHub lanza su API v4 en GraphQL; le siguen Shopify, Netflix y otros.</a:t>
-            </a:r>
-          </a:p>
-        </p:txBody>
-      </p:sp>
-      <p:sp>
-        <p:nvSpPr>
-          <p:cNvPr id="115" name="Card 115"/>
-          <p:cNvSpPr/>
-          <p:nvPr/>
-        </p:nvSpPr>
-        <p:spPr>
-          <a:xfrm>
-            <a:off x="6766560" y="1783080"/>
-            <a:ext cx="1920240" cy="1828800"/>
-          </a:xfrm>
-          <a:prstGeom prst="roundRect">
-            <a:avLst>
-              <a:gd name="adj" fmla="val 5000"/>
-            </a:avLst>
-          </a:prstGeom>
-          <a:solidFill>
-            <a:srgbClr val="F6EEF6"/>
-          </a:solidFill>
-          <a:ln w="9525">
-            <a:solidFill>
-              <a:srgbClr val="E3D6E3"/>
-            </a:solidFill>
-          </a:ln>
-        </p:spPr>
-        <p:txBody>
-          <a:bodyPr/>
-          <a:lstStyle/>
-          <a:p>
-            <a:endParaRPr lang="es-AR"/>
-          </a:p>
-        </p:txBody>
-      </p:sp>
-      <p:sp>
-        <p:nvSpPr>
-          <p:cNvPr id="116" name="Text 116"/>
-          <p:cNvSpPr txBox="1"/>
-          <p:nvPr/>
-        </p:nvSpPr>
-        <p:spPr>
-          <a:xfrm>
-            <a:off x="6949440" y="1920240"/>
-            <a:ext cx="1554480" cy="411480"/>
-          </a:xfrm>
-          <a:prstGeom prst="rect">
-            <a:avLst/>
-          </a:prstGeom>
-          <a:noFill/>
-          <a:ln/>
-        </p:spPr>
-        <p:txBody>
-          <a:bodyPr wrap="square" lIns="0" tIns="0" rIns="0" bIns="0" rtlCol="0" anchor="ctr"/>
-          <a:lstStyle/>
-          <a:p>
-            <a:pPr marL="0" indent="0">
-              <a:buNone/>
-            </a:pPr>
-            <a:r>
-              <a:rPr lang="es-AR" sz="2800" b="1" dirty="0">
-                <a:solidFill>
-                  <a:srgbClr val="E10098"/>
-                </a:solidFill>
-                <a:latin typeface="Cambria" pitchFamily="34" charset="0"/>
-                <a:ea typeface="Cambria" pitchFamily="34" charset="-122"/>
-                <a:cs typeface="Cambria" pitchFamily="34" charset="-120"/>
-              </a:rPr>
-              <a:t>2018</a:t>
-            </a:r>
-          </a:p>
-        </p:txBody>
-      </p:sp>
-      <p:sp>
-        <p:nvSpPr>
-          <p:cNvPr id="117" name="Text 117"/>
-          <p:cNvSpPr txBox="1"/>
-          <p:nvPr/>
-        </p:nvSpPr>
-        <p:spPr>
-          <a:xfrm>
-            <a:off x="6949440" y="2377440"/>
-            <a:ext cx="1554480" cy="274320"/>
-          </a:xfrm>
-          <a:prstGeom prst="rect">
-            <a:avLst/>
-          </a:prstGeom>
-          <a:noFill/>
-          <a:ln/>
-        </p:spPr>
-        <p:txBody>
-          <a:bodyPr wrap="square" lIns="0" tIns="0" rIns="0" bIns="0" rtlCol="0" anchor="ctr"/>
-          <a:lstStyle/>
-          <a:p>
-            <a:pPr marL="0" indent="0">
-              <a:buNone/>
-            </a:pPr>
-            <a:r>
-              <a:rPr lang="es-AR" sz="1400" b="1" dirty="0">
-                <a:solidFill>
-                  <a:srgbClr val="1B1F3B"/>
-                </a:solidFill>
-                <a:latin typeface="Cambria" pitchFamily="34" charset="0"/>
-                <a:ea typeface="Cambria" pitchFamily="34" charset="-122"/>
-                <a:cs typeface="Cambria" pitchFamily="34" charset="-120"/>
-              </a:rPr>
-              <a:t>Fundación propia</a:t>
-            </a:r>
-          </a:p>
-        </p:txBody>
-      </p:sp>
-      <p:sp>
-        <p:nvSpPr>
-          <p:cNvPr id="118" name="Text 118"/>
-          <p:cNvSpPr txBox="1"/>
-          <p:nvPr/>
-        </p:nvSpPr>
-        <p:spPr>
-          <a:xfrm>
-            <a:off x="6949440" y="2743200"/>
-            <a:ext cx="1554480" cy="777240"/>
-          </a:xfrm>
-          <a:prstGeom prst="rect">
-            <a:avLst/>
-          </a:prstGeom>
-          <a:noFill/>
-          <a:ln/>
-        </p:spPr>
-        <p:txBody>
-          <a:bodyPr wrap="square" lIns="0" tIns="0" rIns="0" bIns="0" rtlCol="0" anchor="t"/>
-          <a:lstStyle/>
-          <a:p>
-            <a:pPr marL="0" indent="0">
-              <a:buNone/>
-            </a:pPr>
-            <a:r>
-              <a:rPr lang="es-AR" sz="1200" dirty="0">
-                <a:solidFill>
-                  <a:srgbClr val="5B6178"/>
-                </a:solidFill>
-                <a:latin typeface="Calibri" pitchFamily="34" charset="0"/>
-                <a:ea typeface="Calibri" pitchFamily="34" charset="-122"/>
-                <a:cs typeface="Calibri" pitchFamily="34" charset="-120"/>
-              </a:rPr>
-              <a:t>Pasa a la GraphQL Foundation, dentro de la Linux Foundation.</a:t>
-            </a:r>
-          </a:p>
-        </p:txBody>
-      </p:sp>
-      <p:sp>
-        <p:nvSpPr>
-          <p:cNvPr id="119" name="Banner 119"/>
-          <p:cNvSpPr/>
-          <p:nvPr/>
-        </p:nvSpPr>
-        <p:spPr>
-          <a:xfrm>
-            <a:off x="457200" y="3749040"/>
-            <a:ext cx="8229600" cy="822960"/>
-          </a:xfrm>
-          <a:prstGeom prst="roundRect">
-            <a:avLst>
-              <a:gd name="adj" fmla="val 12500"/>
-            </a:avLst>
-          </a:prstGeom>
-          <a:solidFill>
-            <a:srgbClr val="E10098"/>
-          </a:solidFill>
-          <a:ln>
-            <a:noFill/>
-          </a:ln>
-        </p:spPr>
-        <p:txBody>
-          <a:bodyPr/>
-          <a:lstStyle/>
-          <a:p>
-            <a:endParaRPr lang="es-AR"/>
-          </a:p>
-        </p:txBody>
-      </p:sp>
-      <p:sp>
-        <p:nvSpPr>
-          <p:cNvPr id="120" name="Text 120"/>
-          <p:cNvSpPr txBox="1"/>
-          <p:nvPr/>
-        </p:nvSpPr>
-        <p:spPr>
-          <a:xfrm>
-            <a:off x="640080" y="3817620"/>
-            <a:ext cx="7863840" cy="685800"/>
-          </a:xfrm>
-          <a:prstGeom prst="rect">
-            <a:avLst/>
-          </a:prstGeom>
-          <a:noFill/>
-          <a:ln/>
-        </p:spPr>
-        <p:txBody>
-          <a:bodyPr wrap="square" lIns="0" tIns="0" rIns="0" bIns="0" rtlCol="0" anchor="ctr"/>
-          <a:lstStyle/>
-          <a:p>
-            <a:pPr marL="0" indent="0">
-              <a:buNone/>
-            </a:pPr>
-            <a:r>
-              <a:rPr lang="es-AR" sz="1400" b="1" dirty="0">
-                <a:solidFill>
-                  <a:srgbClr val="FFFFFF"/>
-                </a:solidFill>
-                <a:latin typeface="Cambria" pitchFamily="34" charset="0"/>
-                <a:ea typeface="Cambria" pitchFamily="34" charset="-122"/>
-                <a:cs typeface="Cambria" pitchFamily="34" charset="-120"/>
-              </a:rPr>
-              <a:t>¿Por qué se creó? </a:t>
-            </a:r>
-            <a:r>
-              <a:rPr lang="es-AR" sz="1400" dirty="0">
-                <a:solidFill>
-                  <a:srgbClr val="FFFFFF"/>
-                </a:solidFill>
-                <a:latin typeface="Calibri" pitchFamily="34" charset="0"/>
-                <a:ea typeface="Calibri" pitchFamily="34" charset="-122"/>
-                <a:cs typeface="Calibri" pitchFamily="34" charset="-120"/>
-              </a:rPr>
-              <a:t>Con REST, cada pantalla del celular hacía varias llamadas y recibía datos de más, sobre redes móviles lentas. GraphQL deja que la pantalla pida justo lo que necesita, en una sola llamada.</a:t>
-            </a:r>
-          </a:p>
-        </p:txBody>
-      </p:sp>
-      <p:sp>
-        <p:nvSpPr>
-          <p:cNvPr id="121" name="Text 121"/>
-          <p:cNvSpPr txBox="1"/>
-          <p:nvPr/>
-        </p:nvSpPr>
-        <p:spPr>
-          <a:xfrm>
-            <a:off x="457200" y="4754880"/>
-            <a:ext cx="5486400" cy="228600"/>
-          </a:xfrm>
-          <a:prstGeom prst="rect">
-            <a:avLst/>
-          </a:prstGeom>
-          <a:noFill/>
-          <a:ln/>
-        </p:spPr>
-        <p:txBody>
-          <a:bodyPr wrap="square" lIns="0" tIns="0" rIns="0" bIns="0" rtlCol="0" anchor="ctr"/>
-          <a:lstStyle/>
-          <a:p>
-            <a:pPr marL="0" indent="0">
-              <a:buNone/>
-            </a:pPr>
-            <a:r>
-              <a:rPr lang="es-AR" sz="900" dirty="0">
-                <a:solidFill>
-                  <a:srgbClr val="5B6178"/>
-                </a:solidFill>
-                <a:latin typeface="Calibri" pitchFamily="34" charset="0"/>
-                <a:ea typeface="Calibri" pitchFamily="34" charset="-122"/>
-                <a:cs typeface="Calibri" pitchFamily="34" charset="-120"/>
-              </a:rPr>
-              <a:t>GraphQL y REST · Gamba y Milanesi · 2026</a:t>
-            </a:r>
-          </a:p>
-        </p:txBody>
-      </p:sp>
-      <p:sp>
-        <p:nvSpPr>
-          <p:cNvPr id="122" name="Text 122"/>
-          <p:cNvSpPr txBox="1"/>
-          <p:nvPr/>
-        </p:nvSpPr>
-        <p:spPr>
-          <a:xfrm>
-            <a:off x="8229600" y="4754880"/>
-            <a:ext cx="457200" cy="228600"/>
-          </a:xfrm>
-          <a:prstGeom prst="rect">
-            <a:avLst/>
-          </a:prstGeom>
-          <a:noFill/>
-          <a:ln/>
-        </p:spPr>
-        <p:txBody>
-          <a:bodyPr wrap="square" lIns="0" tIns="0" rIns="0" bIns="0" rtlCol="0" anchor="ctr"/>
-          <a:lstStyle/>
-          <a:p>
-            <a:pPr marL="0" indent="0" algn="r">
-              <a:buNone/>
-            </a:pPr>
-            <a:r>
-              <a:rPr lang="es-AR" sz="900" dirty="0">
-                <a:solidFill>
-                  <a:srgbClr val="5B6178"/>
-                </a:solidFill>
-                <a:latin typeface="Calibri" pitchFamily="34" charset="0"/>
-                <a:ea typeface="Calibri" pitchFamily="34" charset="-122"/>
-                <a:cs typeface="Calibri" pitchFamily="34" charset="-120"/>
-              </a:rPr>
-              <a:t>2</a:t>
-            </a:r>
           </a:p>
         </p:txBody>
       </p:sp>

</xml_diff>